<commit_message>
feat(docs): update README and add project guidelines in consigne.md fix(dashboard): improve title and section note for clarity
</commit_message>
<xml_diff>
--- a/presentation/slides.pptx
+++ b/presentation/slides.pptx
@@ -1976,8 +1976,8 @@
         </p:nvSpPr>
         <p:spPr>
           <a:xfrm>
-            <a:off x="596899" y="5674619"/>
-            <a:ext cx="1283970" cy="264795"/>
+            <a:off x="596898" y="5674619"/>
+            <a:ext cx="1384301" cy="253273"/>
           </a:xfrm>
           <a:prstGeom prst="rect">
             <a:avLst/>
@@ -1998,34 +1998,11 @@
               </a:spcBef>
             </a:pPr>
             <a:r>
-              <a:rPr sz="1550" b="1" spc="-60" dirty="0">
-                <a:solidFill>
-                  <a:srgbClr val="111111"/>
-                </a:solidFill>
+              <a:rPr lang="fr-FR" sz="1550" dirty="0">
                 <a:latin typeface="Arial"/>
                 <a:cs typeface="Arial"/>
               </a:rPr>
-              <a:t>[Prénom</a:t>
-            </a:r>
-            <a:r>
-              <a:rPr sz="1550" b="1" spc="-105" dirty="0">
-                <a:solidFill>
-                  <a:srgbClr val="111111"/>
-                </a:solidFill>
-                <a:latin typeface="Arial"/>
-                <a:cs typeface="Arial"/>
-              </a:rPr>
-              <a:t> </a:t>
-            </a:r>
-            <a:r>
-              <a:rPr sz="1550" b="1" spc="-55" dirty="0">
-                <a:solidFill>
-                  <a:srgbClr val="111111"/>
-                </a:solidFill>
-                <a:latin typeface="Arial"/>
-                <a:cs typeface="Arial"/>
-              </a:rPr>
-              <a:t>Nom]</a:t>
+              <a:t>Amine SLAOUI</a:t>
             </a:r>
             <a:endParaRPr sz="1550" dirty="0">
               <a:latin typeface="Arial"/>
@@ -2043,7 +2020,7 @@
         <p:spPr>
           <a:xfrm>
             <a:off x="2463800" y="5674619"/>
-            <a:ext cx="1283970" cy="264795"/>
+            <a:ext cx="1574800" cy="253273"/>
           </a:xfrm>
           <a:prstGeom prst="rect">
             <a:avLst/>
@@ -2064,166 +2041,11 @@
               </a:spcBef>
             </a:pPr>
             <a:r>
-              <a:rPr sz="1550" b="1" spc="-60" dirty="0">
-                <a:solidFill>
-                  <a:srgbClr val="111111"/>
-                </a:solidFill>
+              <a:rPr lang="fr-FR" sz="1550" dirty="0">
                 <a:latin typeface="Arial"/>
                 <a:cs typeface="Arial"/>
               </a:rPr>
-              <a:t>[Prénom</a:t>
-            </a:r>
-            <a:r>
-              <a:rPr sz="1550" b="1" spc="-105" dirty="0">
-                <a:solidFill>
-                  <a:srgbClr val="111111"/>
-                </a:solidFill>
-                <a:latin typeface="Arial"/>
-                <a:cs typeface="Arial"/>
-              </a:rPr>
-              <a:t> </a:t>
-            </a:r>
-            <a:r>
-              <a:rPr sz="1550" b="1" spc="-55" dirty="0">
-                <a:solidFill>
-                  <a:srgbClr val="111111"/>
-                </a:solidFill>
-                <a:latin typeface="Arial"/>
-                <a:cs typeface="Arial"/>
-              </a:rPr>
-              <a:t>Nom]</a:t>
-            </a:r>
-            <a:endParaRPr sz="1550">
-              <a:latin typeface="Arial"/>
-              <a:cs typeface="Arial"/>
-            </a:endParaRPr>
-          </a:p>
-        </p:txBody>
-      </p:sp>
-      <p:sp>
-        <p:nvSpPr>
-          <p:cNvPr id="7" name="object 7"/>
-          <p:cNvSpPr txBox="1"/>
-          <p:nvPr/>
-        </p:nvSpPr>
-        <p:spPr>
-          <a:xfrm>
-            <a:off x="4330700" y="5674619"/>
-            <a:ext cx="1283970" cy="264795"/>
-          </a:xfrm>
-          <a:prstGeom prst="rect">
-            <a:avLst/>
-          </a:prstGeom>
-        </p:spPr>
-        <p:txBody>
-          <a:bodyPr vert="horz" wrap="square" lIns="0" tIns="14604" rIns="0" bIns="0" rtlCol="0">
-            <a:spAutoFit/>
-          </a:bodyPr>
-          <a:lstStyle/>
-          <a:p>
-            <a:pPr marL="12700">
-              <a:lnSpc>
-                <a:spcPct val="100000"/>
-              </a:lnSpc>
-              <a:spcBef>
-                <a:spcPts val="114"/>
-              </a:spcBef>
-            </a:pPr>
-            <a:r>
-              <a:rPr sz="1550" b="1" spc="-60" dirty="0">
-                <a:solidFill>
-                  <a:srgbClr val="111111"/>
-                </a:solidFill>
-                <a:latin typeface="Arial"/>
-                <a:cs typeface="Arial"/>
-              </a:rPr>
-              <a:t>[Prénom</a:t>
-            </a:r>
-            <a:r>
-              <a:rPr sz="1550" b="1" spc="-105" dirty="0">
-                <a:solidFill>
-                  <a:srgbClr val="111111"/>
-                </a:solidFill>
-                <a:latin typeface="Arial"/>
-                <a:cs typeface="Arial"/>
-              </a:rPr>
-              <a:t> </a:t>
-            </a:r>
-            <a:r>
-              <a:rPr sz="1550" b="1" spc="-55" dirty="0">
-                <a:solidFill>
-                  <a:srgbClr val="111111"/>
-                </a:solidFill>
-                <a:latin typeface="Arial"/>
-                <a:cs typeface="Arial"/>
-              </a:rPr>
-              <a:t>Nom]</a:t>
-            </a:r>
-            <a:endParaRPr sz="1550" dirty="0">
-              <a:latin typeface="Arial"/>
-              <a:cs typeface="Arial"/>
-            </a:endParaRPr>
-          </a:p>
-        </p:txBody>
-      </p:sp>
-      <p:sp>
-        <p:nvSpPr>
-          <p:cNvPr id="8" name="object 8"/>
-          <p:cNvSpPr txBox="1"/>
-          <p:nvPr/>
-        </p:nvSpPr>
-        <p:spPr>
-          <a:xfrm>
-            <a:off x="6197600" y="5674619"/>
-            <a:ext cx="1283970" cy="264795"/>
-          </a:xfrm>
-          <a:prstGeom prst="rect">
-            <a:avLst/>
-          </a:prstGeom>
-        </p:spPr>
-        <p:txBody>
-          <a:bodyPr vert="horz" wrap="square" lIns="0" tIns="14604" rIns="0" bIns="0" rtlCol="0">
-            <a:spAutoFit/>
-          </a:bodyPr>
-          <a:lstStyle/>
-          <a:p>
-            <a:pPr marL="12700">
-              <a:lnSpc>
-                <a:spcPct val="100000"/>
-              </a:lnSpc>
-              <a:spcBef>
-                <a:spcPts val="114"/>
-              </a:spcBef>
-            </a:pPr>
-            <a:r>
-              <a:rPr sz="1550" b="1" spc="-60" dirty="0">
-                <a:solidFill>
-                  <a:srgbClr val="111111"/>
-                </a:solidFill>
-                <a:latin typeface="Arial"/>
-                <a:cs typeface="Arial"/>
-              </a:rPr>
-              <a:t>[Prénom</a:t>
-            </a:r>
-            <a:r>
-              <a:rPr sz="1550" b="1" spc="-105" dirty="0">
-                <a:solidFill>
-                  <a:srgbClr val="111111"/>
-                </a:solidFill>
-                <a:latin typeface="Arial"/>
-                <a:cs typeface="Arial"/>
-              </a:rPr>
-              <a:t> </a:t>
-            </a:r>
-            <a:r>
-              <a:rPr sz="1550" b="1" spc="-55" dirty="0">
-                <a:solidFill>
-                  <a:srgbClr val="111111"/>
-                </a:solidFill>
-                <a:latin typeface="Arial"/>
-                <a:cs typeface="Arial"/>
-              </a:rPr>
-              <a:t>Nom]</a:t>
+              <a:t>Thomas VELARD</a:t>
             </a:r>
             <a:endParaRPr sz="1550" dirty="0">
               <a:latin typeface="Arial"/>
@@ -2342,212 +2164,42 @@
           </a:p>
         </p:txBody>
       </p:sp>
-      <p:sp>
-        <p:nvSpPr>
-          <p:cNvPr id="10" name="object 10"/>
-          <p:cNvSpPr txBox="1"/>
+      <p:pic>
+        <p:nvPicPr>
+          <p:cNvPr id="11" name="Image 10">
+            <a:extLst>
+              <a:ext uri="{FF2B5EF4-FFF2-40B4-BE49-F238E27FC236}">
+                <a16:creationId xmlns:a16="http://schemas.microsoft.com/office/drawing/2014/main" id="{0BB28618-90C1-DA4D-BA48-38F8BE14D6FF}"/>
+              </a:ext>
+            </a:extLst>
+          </p:cNvPr>
+          <p:cNvPicPr>
+            <a:picLocks noChangeAspect="1"/>
+          </p:cNvPicPr>
           <p:nvPr/>
-        </p:nvSpPr>
+        </p:nvPicPr>
+        <p:blipFill>
+          <a:blip r:embed="rId2">
+            <a:extLst>
+              <a:ext uri="{28A0092B-C50C-407E-A947-70E740481C1C}">
+                <a14:useLocalDpi xmlns:a14="http://schemas.microsoft.com/office/drawing/2010/main" val="0"/>
+              </a:ext>
+            </a:extLst>
+          </a:blip>
+          <a:stretch>
+            <a:fillRect/>
+          </a:stretch>
+        </p:blipFill>
         <p:spPr>
           <a:xfrm>
-            <a:off x="596899" y="6335297"/>
-            <a:ext cx="3308985" cy="168910"/>
+            <a:off x="10591800" y="342900"/>
+            <a:ext cx="1271804" cy="1790700"/>
           </a:xfrm>
           <a:prstGeom prst="rect">
             <a:avLst/>
           </a:prstGeom>
         </p:spPr>
-        <p:txBody>
-          <a:bodyPr vert="horz" wrap="square" lIns="0" tIns="11430" rIns="0" bIns="0" rtlCol="0">
-            <a:spAutoFit/>
-          </a:bodyPr>
-          <a:lstStyle/>
-          <a:p>
-            <a:pPr marL="12700">
-              <a:lnSpc>
-                <a:spcPct val="100000"/>
-              </a:lnSpc>
-              <a:spcBef>
-                <a:spcPts val="90"/>
-              </a:spcBef>
-            </a:pPr>
-            <a:r>
-              <a:rPr sz="950" spc="-40" dirty="0">
-                <a:solidFill>
-                  <a:srgbClr val="6A6A6A"/>
-                </a:solidFill>
-                <a:latin typeface="Arial MT"/>
-                <a:cs typeface="Arial MT"/>
-              </a:rPr>
-              <a:t>Membres</a:t>
-            </a:r>
-            <a:r>
-              <a:rPr sz="950" spc="-45" dirty="0">
-                <a:solidFill>
-                  <a:srgbClr val="6A6A6A"/>
-                </a:solidFill>
-                <a:latin typeface="Arial MT"/>
-                <a:cs typeface="Arial MT"/>
-              </a:rPr>
-              <a:t> </a:t>
-            </a:r>
-            <a:r>
-              <a:rPr sz="950" spc="-35" dirty="0">
-                <a:solidFill>
-                  <a:srgbClr val="6A6A6A"/>
-                </a:solidFill>
-                <a:latin typeface="Arial MT"/>
-                <a:cs typeface="Arial MT"/>
-              </a:rPr>
-              <a:t>du</a:t>
-            </a:r>
-            <a:r>
-              <a:rPr sz="950" spc="-10" dirty="0">
-                <a:solidFill>
-                  <a:srgbClr val="6A6A6A"/>
-                </a:solidFill>
-                <a:latin typeface="Arial MT"/>
-                <a:cs typeface="Arial MT"/>
-              </a:rPr>
-              <a:t> </a:t>
-            </a:r>
-            <a:r>
-              <a:rPr sz="950" spc="-35" dirty="0">
-                <a:solidFill>
-                  <a:srgbClr val="6A6A6A"/>
-                </a:solidFill>
-                <a:latin typeface="Arial MT"/>
-                <a:cs typeface="Arial MT"/>
-              </a:rPr>
-              <a:t>groupe</a:t>
-            </a:r>
-            <a:r>
-              <a:rPr sz="950" spc="-45" dirty="0">
-                <a:solidFill>
-                  <a:srgbClr val="6A6A6A"/>
-                </a:solidFill>
-                <a:latin typeface="Arial MT"/>
-                <a:cs typeface="Arial MT"/>
-              </a:rPr>
-              <a:t> </a:t>
-            </a:r>
-            <a:r>
-              <a:rPr sz="950" spc="-120" dirty="0">
-                <a:solidFill>
-                  <a:srgbClr val="6A6A6A"/>
-                </a:solidFill>
-                <a:latin typeface="Arial MT"/>
-                <a:cs typeface="Arial MT"/>
-              </a:rPr>
-              <a:t>·</a:t>
-            </a:r>
-            <a:r>
-              <a:rPr sz="950" spc="75" dirty="0">
-                <a:solidFill>
-                  <a:srgbClr val="6A6A6A"/>
-                </a:solidFill>
-                <a:latin typeface="Arial MT"/>
-                <a:cs typeface="Arial MT"/>
-              </a:rPr>
-              <a:t> </a:t>
-            </a:r>
-            <a:r>
-              <a:rPr sz="950" spc="-35" dirty="0">
-                <a:solidFill>
-                  <a:srgbClr val="6A6A6A"/>
-                </a:solidFill>
-                <a:latin typeface="Arial MT"/>
-                <a:cs typeface="Arial MT"/>
-              </a:rPr>
-              <a:t>Présentation</a:t>
-            </a:r>
-            <a:r>
-              <a:rPr sz="950" spc="-20" dirty="0">
-                <a:solidFill>
-                  <a:srgbClr val="6A6A6A"/>
-                </a:solidFill>
-                <a:latin typeface="Arial MT"/>
-                <a:cs typeface="Arial MT"/>
-              </a:rPr>
-              <a:t> </a:t>
-            </a:r>
-            <a:r>
-              <a:rPr sz="950" spc="-25" dirty="0">
-                <a:solidFill>
-                  <a:srgbClr val="6A6A6A"/>
-                </a:solidFill>
-                <a:latin typeface="Arial MT"/>
-                <a:cs typeface="Arial MT"/>
-              </a:rPr>
-              <a:t>et</a:t>
-            </a:r>
-            <a:r>
-              <a:rPr sz="950" spc="-40" dirty="0">
-                <a:solidFill>
-                  <a:srgbClr val="6A6A6A"/>
-                </a:solidFill>
-                <a:latin typeface="Arial MT"/>
-                <a:cs typeface="Arial MT"/>
-              </a:rPr>
-              <a:t> </a:t>
-            </a:r>
-            <a:r>
-              <a:rPr sz="950" spc="-25" dirty="0">
-                <a:solidFill>
-                  <a:srgbClr val="6A6A6A"/>
-                </a:solidFill>
-                <a:latin typeface="Arial MT"/>
-                <a:cs typeface="Arial MT"/>
-              </a:rPr>
-              <a:t>prototype</a:t>
-            </a:r>
-            <a:r>
-              <a:rPr sz="950" spc="-45" dirty="0">
-                <a:solidFill>
-                  <a:srgbClr val="6A6A6A"/>
-                </a:solidFill>
-                <a:latin typeface="Arial MT"/>
-                <a:cs typeface="Arial MT"/>
-              </a:rPr>
-              <a:t> </a:t>
-            </a:r>
-            <a:r>
-              <a:rPr sz="950" spc="-35" dirty="0">
-                <a:solidFill>
-                  <a:srgbClr val="6A6A6A"/>
-                </a:solidFill>
-                <a:latin typeface="Arial MT"/>
-                <a:cs typeface="Arial MT"/>
-              </a:rPr>
-              <a:t>Docker</a:t>
-            </a:r>
-            <a:r>
-              <a:rPr sz="950" spc="-80" dirty="0">
-                <a:solidFill>
-                  <a:srgbClr val="6A6A6A"/>
-                </a:solidFill>
-                <a:latin typeface="Arial MT"/>
-                <a:cs typeface="Arial MT"/>
-              </a:rPr>
-              <a:t> </a:t>
-            </a:r>
-            <a:r>
-              <a:rPr sz="950" spc="-10" dirty="0">
-                <a:solidFill>
-                  <a:srgbClr val="6A6A6A"/>
-                </a:solidFill>
-                <a:latin typeface="Arial MT"/>
-                <a:cs typeface="Arial MT"/>
-              </a:rPr>
-              <a:t>Compose</a:t>
-            </a:r>
-            <a:endParaRPr sz="950">
-              <a:latin typeface="Arial MT"/>
-              <a:cs typeface="Arial MT"/>
-            </a:endParaRPr>
-          </a:p>
-        </p:txBody>
-      </p:sp>
+      </p:pic>
     </p:spTree>
   </p:cSld>
   <p:clrMapOvr>
@@ -2585,8 +2237,8 @@
         </p:nvSpPr>
         <p:spPr>
           <a:xfrm>
-            <a:off x="596899" y="208048"/>
-            <a:ext cx="4918075" cy="1143635"/>
+            <a:off x="609599" y="619126"/>
+            <a:ext cx="4918075" cy="548227"/>
           </a:xfrm>
           <a:prstGeom prst="rect">
             <a:avLst/>
@@ -2610,23 +2262,7 @@
               </a:tabLst>
             </a:pPr>
             <a:r>
-              <a:rPr sz="7300" spc="265" dirty="0">
-                <a:solidFill>
-                  <a:srgbClr val="1F36C7"/>
-                </a:solidFill>
-              </a:rPr>
-              <a:t>01</a:t>
-            </a:r>
-            <a:r>
-              <a:rPr sz="7300" dirty="0">
-                <a:solidFill>
-                  <a:srgbClr val="1F36C7"/>
-                </a:solidFill>
-              </a:rPr>
-              <a:t>	</a:t>
-            </a:r>
-            <a:r>
-              <a:rPr spc="-75" dirty="0"/>
+              <a:rPr spc="-75" dirty="0" err="1"/>
               <a:t>Besoins</a:t>
             </a:r>
             <a:r>
@@ -2637,7 +2273,7 @@
               <a:rPr spc="-10" dirty="0"/>
               <a:t>métier</a:t>
             </a:r>
-            <a:endParaRPr sz="7300"/>
+            <a:endParaRPr sz="7300" dirty="0"/>
           </a:p>
         </p:txBody>
       </p:sp>
@@ -2650,7 +2286,7 @@
         <p:spPr>
           <a:xfrm>
             <a:off x="596899" y="1641230"/>
-            <a:ext cx="6946265" cy="1286510"/>
+            <a:ext cx="6946265" cy="711092"/>
           </a:xfrm>
           <a:prstGeom prst="rect">
             <a:avLst/>
@@ -3035,147 +2671,6 @@
               <a:cs typeface="Arial"/>
             </a:endParaRPr>
           </a:p>
-          <a:p>
-            <a:pPr>
-              <a:lnSpc>
-                <a:spcPct val="100000"/>
-              </a:lnSpc>
-              <a:spcBef>
-                <a:spcPts val="30"/>
-              </a:spcBef>
-            </a:pPr>
-            <a:endParaRPr sz="2250" dirty="0">
-              <a:latin typeface="Arial"/>
-              <a:cs typeface="Arial"/>
-            </a:endParaRPr>
-          </a:p>
-          <a:p>
-            <a:pPr marL="12700">
-              <a:lnSpc>
-                <a:spcPct val="100000"/>
-              </a:lnSpc>
-              <a:spcBef>
-                <a:spcPts val="5"/>
-              </a:spcBef>
-              <a:tabLst>
-                <a:tab pos="3745865" algn="l"/>
-              </a:tabLst>
-            </a:pPr>
-            <a:r>
-              <a:rPr sz="1500" b="1" dirty="0">
-                <a:solidFill>
-                  <a:srgbClr val="111111"/>
-                </a:solidFill>
-                <a:latin typeface="Arial"/>
-                <a:cs typeface="Arial"/>
-              </a:rPr>
-              <a:t>Ingénieurs</a:t>
-            </a:r>
-            <a:r>
-              <a:rPr sz="1500" b="1" spc="-125" dirty="0">
-                <a:solidFill>
-                  <a:srgbClr val="111111"/>
-                </a:solidFill>
-                <a:latin typeface="Arial"/>
-                <a:cs typeface="Arial"/>
-              </a:rPr>
-              <a:t> </a:t>
-            </a:r>
-            <a:r>
-              <a:rPr sz="1500" b="1" dirty="0">
-                <a:solidFill>
-                  <a:srgbClr val="111111"/>
-                </a:solidFill>
-                <a:latin typeface="Arial"/>
-                <a:cs typeface="Arial"/>
-              </a:rPr>
-              <a:t>de</a:t>
-            </a:r>
-            <a:r>
-              <a:rPr sz="1500" b="1" spc="-125" dirty="0">
-                <a:solidFill>
-                  <a:srgbClr val="111111"/>
-                </a:solidFill>
-                <a:latin typeface="Arial"/>
-                <a:cs typeface="Arial"/>
-              </a:rPr>
-              <a:t> </a:t>
-            </a:r>
-            <a:r>
-              <a:rPr sz="1500" b="1" spc="-10" dirty="0">
-                <a:solidFill>
-                  <a:srgbClr val="111111"/>
-                </a:solidFill>
-                <a:latin typeface="Arial"/>
-                <a:cs typeface="Arial"/>
-              </a:rPr>
-              <a:t>production</a:t>
-            </a:r>
-            <a:r>
-              <a:rPr sz="1500" b="1" dirty="0">
-                <a:solidFill>
-                  <a:srgbClr val="111111"/>
-                </a:solidFill>
-                <a:latin typeface="Arial"/>
-                <a:cs typeface="Arial"/>
-              </a:rPr>
-              <a:t>	</a:t>
-            </a:r>
-            <a:r>
-              <a:rPr sz="1500" b="1" spc="-10" dirty="0">
-                <a:solidFill>
-                  <a:srgbClr val="111111"/>
-                </a:solidFill>
-                <a:latin typeface="Arial"/>
-                <a:cs typeface="Arial"/>
-              </a:rPr>
-              <a:t>Équipes</a:t>
-            </a:r>
-            <a:r>
-              <a:rPr sz="1500" b="1" spc="-120" dirty="0">
-                <a:solidFill>
-                  <a:srgbClr val="111111"/>
-                </a:solidFill>
-                <a:latin typeface="Arial"/>
-                <a:cs typeface="Arial"/>
-              </a:rPr>
-              <a:t> </a:t>
-            </a:r>
-            <a:r>
-              <a:rPr sz="1500" b="1" dirty="0">
-                <a:solidFill>
-                  <a:srgbClr val="111111"/>
-                </a:solidFill>
-                <a:latin typeface="Arial"/>
-                <a:cs typeface="Arial"/>
-              </a:rPr>
-              <a:t>de</a:t>
-            </a:r>
-            <a:r>
-              <a:rPr sz="1500" b="1" spc="-120" dirty="0">
-                <a:solidFill>
-                  <a:srgbClr val="111111"/>
-                </a:solidFill>
-                <a:latin typeface="Arial"/>
-                <a:cs typeface="Arial"/>
-              </a:rPr>
-              <a:t> </a:t>
-            </a:r>
-            <a:r>
-              <a:rPr sz="1500" b="1" spc="-10" dirty="0">
-                <a:solidFill>
-                  <a:srgbClr val="111111"/>
-                </a:solidFill>
-                <a:latin typeface="Arial"/>
-                <a:cs typeface="Arial"/>
-              </a:rPr>
-              <a:t>maintenance</a:t>
-            </a:r>
-            <a:endParaRPr sz="1500" dirty="0">
-              <a:latin typeface="Arial"/>
-              <a:cs typeface="Arial"/>
-            </a:endParaRPr>
-          </a:p>
         </p:txBody>
       </p:sp>
       <p:sp>
@@ -3187,7 +2682,7 @@
         <p:spPr>
           <a:xfrm>
             <a:off x="8064499" y="2674353"/>
-            <a:ext cx="1788795" cy="253365"/>
+            <a:ext cx="2070101" cy="242374"/>
           </a:xfrm>
           <a:prstGeom prst="rect">
             <a:avLst/>
@@ -3208,9 +2703,9 @@
               </a:spcBef>
             </a:pPr>
             <a:r>
-              <a:rPr sz="1500" b="1" dirty="0">
-                <a:solidFill>
-                  <a:srgbClr val="1F36C7"/>
+              <a:rPr sz="1500" b="1" dirty="0" err="1">
+                <a:solidFill>
+                  <a:srgbClr val="C00000"/>
                 </a:solidFill>
                 <a:latin typeface="Arial"/>
                 <a:cs typeface="Arial"/>
@@ -3220,7 +2715,7 @@
             <a:r>
               <a:rPr sz="1500" b="1" spc="-35" dirty="0">
                 <a:solidFill>
-                  <a:srgbClr val="1F36C7"/>
+                  <a:srgbClr val="C00000"/>
                 </a:solidFill>
                 <a:latin typeface="Arial"/>
                 <a:cs typeface="Arial"/>
@@ -3228,169 +2723,32 @@
               <a:t> </a:t>
             </a:r>
             <a:r>
-              <a:rPr sz="1500" b="1" spc="-10" dirty="0">
-                <a:solidFill>
-                  <a:srgbClr val="1F36C7"/>
+              <a:rPr sz="1500" b="1" spc="-10" dirty="0" err="1">
+                <a:solidFill>
+                  <a:srgbClr val="C00000"/>
                 </a:solidFill>
                 <a:latin typeface="Arial"/>
                 <a:cs typeface="Arial"/>
               </a:rPr>
               <a:t>attendus</a:t>
             </a:r>
-            <a:endParaRPr sz="1500">
+            <a:r>
+              <a:rPr lang="fr-FR" sz="1500" b="1" spc="-10" dirty="0">
+                <a:solidFill>
+                  <a:srgbClr val="C00000"/>
+                </a:solidFill>
+                <a:latin typeface="Arial"/>
+                <a:cs typeface="Arial"/>
+              </a:rPr>
+              <a:t> :</a:t>
+            </a:r>
+            <a:endParaRPr sz="1500" dirty="0">
+              <a:solidFill>
+                <a:srgbClr val="C00000"/>
+              </a:solidFill>
               <a:latin typeface="Arial"/>
               <a:cs typeface="Arial"/>
             </a:endParaRPr>
-          </a:p>
-        </p:txBody>
-      </p:sp>
-      <p:sp>
-        <p:nvSpPr>
-          <p:cNvPr id="4" name="object 4"/>
-          <p:cNvSpPr/>
-          <p:nvPr/>
-        </p:nvSpPr>
-        <p:spPr>
-          <a:xfrm>
-            <a:off x="609599" y="3028949"/>
-            <a:ext cx="3505200" cy="9525"/>
-          </a:xfrm>
-          <a:custGeom>
-            <a:avLst/>
-            <a:gdLst/>
-            <a:ahLst/>
-            <a:cxnLst/>
-            <a:rect l="l" t="t" r="r" b="b"/>
-            <a:pathLst>
-              <a:path w="3505200" h="9525">
-                <a:moveTo>
-                  <a:pt x="3505199" y="9524"/>
-                </a:moveTo>
-                <a:lnTo>
-                  <a:pt x="0" y="9524"/>
-                </a:lnTo>
-                <a:lnTo>
-                  <a:pt x="0" y="0"/>
-                </a:lnTo>
-                <a:lnTo>
-                  <a:pt x="3505199" y="0"/>
-                </a:lnTo>
-                <a:lnTo>
-                  <a:pt x="3505199" y="9524"/>
-                </a:lnTo>
-                <a:close/>
-              </a:path>
-            </a:pathLst>
-          </a:custGeom>
-          <a:solidFill>
-            <a:srgbClr val="111111"/>
-          </a:solidFill>
-        </p:spPr>
-        <p:txBody>
-          <a:bodyPr wrap="square" lIns="0" tIns="0" rIns="0" bIns="0" rtlCol="0"/>
-          <a:lstStyle/>
-          <a:p>
-            <a:endParaRPr/>
-          </a:p>
-        </p:txBody>
-      </p:sp>
-      <p:sp>
-        <p:nvSpPr>
-          <p:cNvPr id="8" name="object 8"/>
-          <p:cNvSpPr/>
-          <p:nvPr/>
-        </p:nvSpPr>
-        <p:spPr>
-          <a:xfrm>
-            <a:off x="4343399" y="3028949"/>
-            <a:ext cx="3505200" cy="9525"/>
-          </a:xfrm>
-          <a:custGeom>
-            <a:avLst/>
-            <a:gdLst/>
-            <a:ahLst/>
-            <a:cxnLst/>
-            <a:rect l="l" t="t" r="r" b="b"/>
-            <a:pathLst>
-              <a:path w="3505200" h="9525">
-                <a:moveTo>
-                  <a:pt x="3505199" y="9524"/>
-                </a:moveTo>
-                <a:lnTo>
-                  <a:pt x="0" y="9524"/>
-                </a:lnTo>
-                <a:lnTo>
-                  <a:pt x="0" y="0"/>
-                </a:lnTo>
-                <a:lnTo>
-                  <a:pt x="3505199" y="0"/>
-                </a:lnTo>
-                <a:lnTo>
-                  <a:pt x="3505199" y="9524"/>
-                </a:lnTo>
-                <a:close/>
-              </a:path>
-            </a:pathLst>
-          </a:custGeom>
-          <a:solidFill>
-            <a:srgbClr val="111111"/>
-          </a:solidFill>
-        </p:spPr>
-        <p:txBody>
-          <a:bodyPr wrap="square" lIns="0" tIns="0" rIns="0" bIns="0" rtlCol="0"/>
-          <a:lstStyle/>
-          <a:p>
-            <a:endParaRPr/>
-          </a:p>
-        </p:txBody>
-      </p:sp>
-      <p:sp>
-        <p:nvSpPr>
-          <p:cNvPr id="14" name="object 14"/>
-          <p:cNvSpPr/>
-          <p:nvPr/>
-        </p:nvSpPr>
-        <p:spPr>
-          <a:xfrm>
-            <a:off x="8077199" y="3028949"/>
-            <a:ext cx="3505200" cy="9525"/>
-          </a:xfrm>
-          <a:custGeom>
-            <a:avLst/>
-            <a:gdLst/>
-            <a:ahLst/>
-            <a:cxnLst/>
-            <a:rect l="l" t="t" r="r" b="b"/>
-            <a:pathLst>
-              <a:path w="3505200" h="9525">
-                <a:moveTo>
-                  <a:pt x="3505199" y="9524"/>
-                </a:moveTo>
-                <a:lnTo>
-                  <a:pt x="0" y="9524"/>
-                </a:lnTo>
-                <a:lnTo>
-                  <a:pt x="0" y="0"/>
-                </a:lnTo>
-                <a:lnTo>
-                  <a:pt x="3505199" y="0"/>
-                </a:lnTo>
-                <a:lnTo>
-                  <a:pt x="3505199" y="9524"/>
-                </a:lnTo>
-                <a:close/>
-              </a:path>
-            </a:pathLst>
-          </a:custGeom>
-          <a:solidFill>
-            <a:srgbClr val="1F36C7"/>
-          </a:solidFill>
-        </p:spPr>
-        <p:txBody>
-          <a:bodyPr wrap="square" lIns="0" tIns="0" rIns="0" bIns="0" rtlCol="0"/>
-          <a:lstStyle/>
-          <a:p>
-            <a:endParaRPr/>
           </a:p>
         </p:txBody>
       </p:sp>
@@ -3723,7 +3081,7 @@
               </a:rPr>
               <a:t>critique.</a:t>
             </a:r>
-            <a:endParaRPr sz="1400">
+            <a:endParaRPr sz="1400" dirty="0">
               <a:latin typeface="Arial MT"/>
               <a:cs typeface="Arial MT"/>
             </a:endParaRPr>
@@ -4019,110 +3377,10 @@
               </a:rPr>
               <a:t>page.</a:t>
             </a:r>
-            <a:endParaRPr sz="1400">
+            <a:endParaRPr sz="1400" dirty="0">
               <a:latin typeface="Arial MT"/>
               <a:cs typeface="Arial MT"/>
             </a:endParaRPr>
-          </a:p>
-        </p:txBody>
-      </p:sp>
-      <p:sp>
-        <p:nvSpPr>
-          <p:cNvPr id="5" name="object 5"/>
-          <p:cNvSpPr/>
-          <p:nvPr/>
-        </p:nvSpPr>
-        <p:spPr>
-          <a:xfrm>
-            <a:off x="609599" y="3800474"/>
-            <a:ext cx="3505200" cy="9525"/>
-          </a:xfrm>
-          <a:custGeom>
-            <a:avLst/>
-            <a:gdLst/>
-            <a:ahLst/>
-            <a:cxnLst/>
-            <a:rect l="l" t="t" r="r" b="b"/>
-            <a:pathLst>
-              <a:path w="3505200" h="9525">
-                <a:moveTo>
-                  <a:pt x="3505199" y="9524"/>
-                </a:moveTo>
-                <a:lnTo>
-                  <a:pt x="0" y="9524"/>
-                </a:lnTo>
-                <a:lnTo>
-                  <a:pt x="0" y="0"/>
-                </a:lnTo>
-                <a:lnTo>
-                  <a:pt x="3505199" y="0"/>
-                </a:lnTo>
-                <a:lnTo>
-                  <a:pt x="3505199" y="9524"/>
-                </a:lnTo>
-                <a:close/>
-              </a:path>
-            </a:pathLst>
-          </a:custGeom>
-          <a:solidFill>
-            <a:srgbClr val="D5D5D5"/>
-          </a:solidFill>
-        </p:spPr>
-        <p:txBody>
-          <a:bodyPr wrap="square" lIns="0" tIns="0" rIns="0" bIns="0" rtlCol="0"/>
-          <a:lstStyle/>
-          <a:p>
-            <a:endParaRPr/>
-          </a:p>
-        </p:txBody>
-      </p:sp>
-      <p:sp>
-        <p:nvSpPr>
-          <p:cNvPr id="9" name="object 9"/>
-          <p:cNvSpPr/>
-          <p:nvPr/>
-        </p:nvSpPr>
-        <p:spPr>
-          <a:xfrm>
-            <a:off x="4343399" y="3800474"/>
-            <a:ext cx="3505200" cy="9525"/>
-          </a:xfrm>
-          <a:custGeom>
-            <a:avLst/>
-            <a:gdLst/>
-            <a:ahLst/>
-            <a:cxnLst/>
-            <a:rect l="l" t="t" r="r" b="b"/>
-            <a:pathLst>
-              <a:path w="3505200" h="9525">
-                <a:moveTo>
-                  <a:pt x="3505199" y="9524"/>
-                </a:moveTo>
-                <a:lnTo>
-                  <a:pt x="0" y="9524"/>
-                </a:lnTo>
-                <a:lnTo>
-                  <a:pt x="0" y="0"/>
-                </a:lnTo>
-                <a:lnTo>
-                  <a:pt x="3505199" y="0"/>
-                </a:lnTo>
-                <a:lnTo>
-                  <a:pt x="3505199" y="9524"/>
-                </a:lnTo>
-                <a:close/>
-              </a:path>
-            </a:pathLst>
-          </a:custGeom>
-          <a:solidFill>
-            <a:srgbClr val="D5D5D5"/>
-          </a:solidFill>
-        </p:spPr>
-        <p:txBody>
-          <a:bodyPr wrap="square" lIns="0" tIns="0" rIns="0" bIns="0" rtlCol="0"/>
-          <a:lstStyle/>
-          <a:p>
-            <a:endParaRPr/>
           </a:p>
         </p:txBody>
       </p:sp>
@@ -4415,7 +3673,7 @@
               </a:rPr>
               <a:t>casse.</a:t>
             </a:r>
-            <a:endParaRPr sz="1400">
+            <a:endParaRPr sz="1400" dirty="0">
               <a:latin typeface="Arial MT"/>
               <a:cs typeface="Arial MT"/>
             </a:endParaRPr>
@@ -4430,8 +3688,8 @@
         </p:nvSpPr>
         <p:spPr>
           <a:xfrm>
-            <a:off x="596899" y="3852193"/>
-            <a:ext cx="3571240" cy="1406525"/>
+            <a:off x="596899" y="4028228"/>
+            <a:ext cx="3571240" cy="716606"/>
           </a:xfrm>
           <a:prstGeom prst="rect">
             <a:avLst/>
@@ -4652,6 +3910,16 @@
               <a:t>une </a:t>
             </a:r>
             <a:r>
+              <a:rPr sz="1400" spc="-10" dirty="0" err="1">
+                <a:solidFill>
+                  <a:srgbClr val="111111"/>
+                </a:solidFill>
+                <a:latin typeface="Arial MT"/>
+                <a:cs typeface="Arial MT"/>
+              </a:rPr>
+              <a:t>dérive</a:t>
+            </a:r>
+            <a:r>
               <a:rPr sz="1400" spc="-10" dirty="0">
                 <a:solidFill>
                   <a:srgbClr val="111111"/>
@@ -4659,192 +3927,9 @@
                 <a:latin typeface="Arial MT"/>
                 <a:cs typeface="Arial MT"/>
               </a:rPr>
-              <a:t>dérive.</a:t>
-            </a:r>
-            <a:endParaRPr sz="1400">
-              <a:latin typeface="Arial MT"/>
-              <a:cs typeface="Arial MT"/>
-            </a:endParaRPr>
-          </a:p>
-          <a:p>
-            <a:pPr marL="12700">
-              <a:lnSpc>
-                <a:spcPts val="1415"/>
-              </a:lnSpc>
-              <a:tabLst>
-                <a:tab pos="3557904" algn="l"/>
-              </a:tabLst>
-            </a:pPr>
-            <a:r>
-              <a:rPr sz="1350" u="sng" dirty="0">
-                <a:solidFill>
-                  <a:srgbClr val="111111"/>
-                </a:solidFill>
-                <a:uFill>
-                  <a:solidFill>
-                    <a:srgbClr val="D5D5D5"/>
-                  </a:solidFill>
-                </a:uFill>
-                <a:latin typeface="Times New Roman"/>
-                <a:cs typeface="Times New Roman"/>
-              </a:rPr>
-              <a:t>	</a:t>
-            </a:r>
-            <a:endParaRPr sz="1350">
-              <a:latin typeface="Times New Roman"/>
-              <a:cs typeface="Times New Roman"/>
-            </a:endParaRPr>
-          </a:p>
-          <a:p>
-            <a:pPr marL="12700" marR="1033780">
-              <a:lnSpc>
-                <a:spcPct val="111600"/>
-              </a:lnSpc>
-              <a:spcBef>
-                <a:spcPts val="85"/>
-              </a:spcBef>
-            </a:pPr>
-            <a:r>
-              <a:rPr sz="1400" b="1" spc="-40" dirty="0">
-                <a:solidFill>
-                  <a:srgbClr val="111111"/>
-                </a:solidFill>
-                <a:latin typeface="Arial"/>
-                <a:cs typeface="Arial"/>
-              </a:rPr>
-              <a:t>Des</a:t>
-            </a:r>
-            <a:r>
-              <a:rPr sz="1400" b="1" spc="-90" dirty="0">
-                <a:solidFill>
-                  <a:srgbClr val="111111"/>
-                </a:solidFill>
-                <a:latin typeface="Arial"/>
-                <a:cs typeface="Arial"/>
-              </a:rPr>
-              <a:t> </a:t>
-            </a:r>
-            <a:r>
-              <a:rPr sz="1400" b="1" spc="-60" dirty="0">
-                <a:solidFill>
-                  <a:srgbClr val="111111"/>
-                </a:solidFill>
-                <a:latin typeface="Arial"/>
-                <a:cs typeface="Arial"/>
-              </a:rPr>
-              <a:t>seuils</a:t>
-            </a:r>
-            <a:r>
-              <a:rPr sz="1400" b="1" spc="-90" dirty="0">
-                <a:solidFill>
-                  <a:srgbClr val="111111"/>
-                </a:solidFill>
-                <a:latin typeface="Arial"/>
-                <a:cs typeface="Arial"/>
-              </a:rPr>
-              <a:t> </a:t>
-            </a:r>
-            <a:r>
-              <a:rPr sz="1400" b="1" spc="-55" dirty="0">
-                <a:solidFill>
-                  <a:srgbClr val="111111"/>
-                </a:solidFill>
-                <a:latin typeface="Arial"/>
-                <a:cs typeface="Arial"/>
-              </a:rPr>
-              <a:t>explicites</a:t>
-            </a:r>
-            <a:r>
-              <a:rPr sz="1400" b="1" spc="-70" dirty="0">
-                <a:solidFill>
-                  <a:srgbClr val="111111"/>
-                </a:solidFill>
-                <a:latin typeface="Arial"/>
-                <a:cs typeface="Arial"/>
-              </a:rPr>
-              <a:t> </a:t>
-            </a:r>
-            <a:r>
-              <a:rPr sz="1400" spc="-30" dirty="0">
-                <a:solidFill>
-                  <a:srgbClr val="111111"/>
-                </a:solidFill>
-                <a:latin typeface="Arial MT"/>
-                <a:cs typeface="Arial MT"/>
-              </a:rPr>
-              <a:t>par</a:t>
-            </a:r>
-            <a:r>
-              <a:rPr sz="1400" spc="-110" dirty="0">
-                <a:solidFill>
-                  <a:srgbClr val="111111"/>
-                </a:solidFill>
-                <a:latin typeface="Arial MT"/>
-                <a:cs typeface="Arial MT"/>
-              </a:rPr>
-              <a:t> </a:t>
-            </a:r>
-            <a:r>
-              <a:rPr sz="1400" spc="-35" dirty="0">
-                <a:solidFill>
-                  <a:srgbClr val="111111"/>
-                </a:solidFill>
-                <a:latin typeface="Arial MT"/>
-                <a:cs typeface="Arial MT"/>
-              </a:rPr>
-              <a:t>capteur, </a:t>
-            </a:r>
-            <a:r>
-              <a:rPr sz="1400" spc="-30" dirty="0">
-                <a:solidFill>
-                  <a:srgbClr val="111111"/>
-                </a:solidFill>
-                <a:latin typeface="Arial MT"/>
-                <a:cs typeface="Arial MT"/>
-              </a:rPr>
-              <a:t>avertissement</a:t>
-            </a:r>
-            <a:r>
-              <a:rPr sz="1400" spc="-50" dirty="0">
-                <a:solidFill>
-                  <a:srgbClr val="111111"/>
-                </a:solidFill>
-                <a:latin typeface="Arial MT"/>
-                <a:cs typeface="Arial MT"/>
-              </a:rPr>
-              <a:t> </a:t>
-            </a:r>
-            <a:r>
-              <a:rPr sz="1400" spc="-20" dirty="0">
-                <a:solidFill>
-                  <a:srgbClr val="111111"/>
-                </a:solidFill>
-                <a:latin typeface="Arial MT"/>
-                <a:cs typeface="Arial MT"/>
-              </a:rPr>
-              <a:t>puis</a:t>
-            </a:r>
-            <a:r>
-              <a:rPr sz="1400" spc="-55" dirty="0">
-                <a:solidFill>
-                  <a:srgbClr val="111111"/>
-                </a:solidFill>
-                <a:latin typeface="Arial MT"/>
-                <a:cs typeface="Arial MT"/>
-              </a:rPr>
-              <a:t> </a:t>
-            </a:r>
-            <a:r>
-              <a:rPr sz="1400" spc="-10" dirty="0">
-                <a:solidFill>
-                  <a:srgbClr val="111111"/>
-                </a:solidFill>
-                <a:latin typeface="Arial MT"/>
-                <a:cs typeface="Arial MT"/>
-              </a:rPr>
-              <a:t>critique.</a:t>
-            </a:r>
-            <a:endParaRPr sz="1400">
+              <a:t>.</a:t>
+            </a:r>
+            <a:endParaRPr sz="1400" dirty="0">
               <a:latin typeface="Arial MT"/>
               <a:cs typeface="Arial MT"/>
             </a:endParaRPr>
@@ -4859,7 +3944,7 @@
         </p:nvSpPr>
         <p:spPr>
           <a:xfrm>
-            <a:off x="4330700" y="3852193"/>
+            <a:off x="4330700" y="3856578"/>
             <a:ext cx="3237865" cy="501650"/>
           </a:xfrm>
           <a:prstGeom prst="rect">
@@ -5080,110 +4165,10 @@
               </a:rPr>
               <a:t>franchissement.</a:t>
             </a:r>
-            <a:endParaRPr sz="1400">
+            <a:endParaRPr sz="1400" dirty="0">
               <a:latin typeface="Arial MT"/>
               <a:cs typeface="Arial MT"/>
             </a:endParaRPr>
-          </a:p>
-        </p:txBody>
-      </p:sp>
-      <p:sp>
-        <p:nvSpPr>
-          <p:cNvPr id="15" name="object 15"/>
-          <p:cNvSpPr/>
-          <p:nvPr/>
-        </p:nvSpPr>
-        <p:spPr>
-          <a:xfrm>
-            <a:off x="8077199" y="4038599"/>
-            <a:ext cx="3505200" cy="9525"/>
-          </a:xfrm>
-          <a:custGeom>
-            <a:avLst/>
-            <a:gdLst/>
-            <a:ahLst/>
-            <a:cxnLst/>
-            <a:rect l="l" t="t" r="r" b="b"/>
-            <a:pathLst>
-              <a:path w="3505200" h="9525">
-                <a:moveTo>
-                  <a:pt x="3505199" y="9524"/>
-                </a:moveTo>
-                <a:lnTo>
-                  <a:pt x="0" y="9524"/>
-                </a:lnTo>
-                <a:lnTo>
-                  <a:pt x="0" y="0"/>
-                </a:lnTo>
-                <a:lnTo>
-                  <a:pt x="3505199" y="0"/>
-                </a:lnTo>
-                <a:lnTo>
-                  <a:pt x="3505199" y="9524"/>
-                </a:lnTo>
-                <a:close/>
-              </a:path>
-            </a:pathLst>
-          </a:custGeom>
-          <a:solidFill>
-            <a:srgbClr val="D5D5D5"/>
-          </a:solidFill>
-        </p:spPr>
-        <p:txBody>
-          <a:bodyPr wrap="square" lIns="0" tIns="0" rIns="0" bIns="0" rtlCol="0"/>
-          <a:lstStyle/>
-          <a:p>
-            <a:endParaRPr/>
-          </a:p>
-        </p:txBody>
-      </p:sp>
-      <p:sp>
-        <p:nvSpPr>
-          <p:cNvPr id="10" name="object 10"/>
-          <p:cNvSpPr/>
-          <p:nvPr/>
-        </p:nvSpPr>
-        <p:spPr>
-          <a:xfrm>
-            <a:off x="4343399" y="4457699"/>
-            <a:ext cx="3505200" cy="9525"/>
-          </a:xfrm>
-          <a:custGeom>
-            <a:avLst/>
-            <a:gdLst/>
-            <a:ahLst/>
-            <a:cxnLst/>
-            <a:rect l="l" t="t" r="r" b="b"/>
-            <a:pathLst>
-              <a:path w="3505200" h="9525">
-                <a:moveTo>
-                  <a:pt x="3505199" y="9524"/>
-                </a:moveTo>
-                <a:lnTo>
-                  <a:pt x="0" y="9524"/>
-                </a:lnTo>
-                <a:lnTo>
-                  <a:pt x="0" y="0"/>
-                </a:lnTo>
-                <a:lnTo>
-                  <a:pt x="3505199" y="0"/>
-                </a:lnTo>
-                <a:lnTo>
-                  <a:pt x="3505199" y="9524"/>
-                </a:lnTo>
-                <a:close/>
-              </a:path>
-            </a:pathLst>
-          </a:custGeom>
-          <a:solidFill>
-            <a:srgbClr val="D5D5D5"/>
-          </a:solidFill>
-        </p:spPr>
-        <p:txBody>
-          <a:bodyPr wrap="square" lIns="0" tIns="0" rIns="0" bIns="0" rtlCol="0"/>
-          <a:lstStyle/>
-          <a:p>
-            <a:endParaRPr/>
           </a:p>
         </p:txBody>
       </p:sp>
@@ -5195,7 +4180,7 @@
         </p:nvSpPr>
         <p:spPr>
           <a:xfrm>
-            <a:off x="4330700" y="4499893"/>
+            <a:off x="4343399" y="4623633"/>
             <a:ext cx="3358515" cy="520700"/>
           </a:xfrm>
           <a:prstGeom prst="rect">
@@ -5396,7 +4381,7 @@
               </a:rPr>
               <a:t>enregistrée.</a:t>
             </a:r>
-            <a:endParaRPr sz="1400">
+            <a:endParaRPr sz="1400" dirty="0">
               <a:latin typeface="Arial MT"/>
               <a:cs typeface="Arial MT"/>
             </a:endParaRPr>
@@ -5671,56 +4656,6 @@
       </p:sp>
       <p:sp>
         <p:nvSpPr>
-          <p:cNvPr id="16" name="object 16"/>
-          <p:cNvSpPr/>
-          <p:nvPr/>
-        </p:nvSpPr>
-        <p:spPr>
-          <a:xfrm>
-            <a:off x="8077199" y="4943474"/>
-            <a:ext cx="3505200" cy="9525"/>
-          </a:xfrm>
-          <a:custGeom>
-            <a:avLst/>
-            <a:gdLst/>
-            <a:ahLst/>
-            <a:cxnLst/>
-            <a:rect l="l" t="t" r="r" b="b"/>
-            <a:pathLst>
-              <a:path w="3505200" h="9525">
-                <a:moveTo>
-                  <a:pt x="3505199" y="9524"/>
-                </a:moveTo>
-                <a:lnTo>
-                  <a:pt x="0" y="9524"/>
-                </a:lnTo>
-                <a:lnTo>
-                  <a:pt x="0" y="0"/>
-                </a:lnTo>
-                <a:lnTo>
-                  <a:pt x="3505199" y="0"/>
-                </a:lnTo>
-                <a:lnTo>
-                  <a:pt x="3505199" y="9524"/>
-                </a:lnTo>
-                <a:close/>
-              </a:path>
-            </a:pathLst>
-          </a:custGeom>
-          <a:solidFill>
-            <a:srgbClr val="D5D5D5"/>
-          </a:solidFill>
-        </p:spPr>
-        <p:txBody>
-          <a:bodyPr wrap="square" lIns="0" tIns="0" rIns="0" bIns="0" rtlCol="0"/>
-          <a:lstStyle/>
-          <a:p>
-            <a:endParaRPr/>
-          </a:p>
-        </p:txBody>
-      </p:sp>
-      <p:sp>
-        <p:nvSpPr>
           <p:cNvPr id="20" name="object 20"/>
           <p:cNvSpPr txBox="1"/>
           <p:nvPr/>
@@ -5968,7 +4903,7 @@
               </a:rPr>
               <a:t>audit.</a:t>
             </a:r>
-            <a:endParaRPr sz="1400">
+            <a:endParaRPr sz="1400" dirty="0">
               <a:latin typeface="Arial MT"/>
               <a:cs typeface="Arial MT"/>
             </a:endParaRPr>
@@ -6021,6 +4956,7 @@
           <a:bodyPr wrap="square" lIns="0" tIns="0" rIns="0" bIns="0" rtlCol="0"/>
           <a:lstStyle/>
           <a:p>
+            <a:pPr algn="l" rtl="0"/>
             <a:endParaRPr/>
           </a:p>
         </p:txBody>
@@ -6104,6 +5040,391 @@
               <a:rPr spc="-50" dirty="0"/>
               <a:t>4</a:t>
             </a:r>
+          </a:p>
+        </p:txBody>
+      </p:sp>
+      <p:pic>
+        <p:nvPicPr>
+          <p:cNvPr id="24" name="Image 23">
+            <a:extLst>
+              <a:ext uri="{FF2B5EF4-FFF2-40B4-BE49-F238E27FC236}">
+                <a16:creationId xmlns:a16="http://schemas.microsoft.com/office/drawing/2014/main" id="{83272B8A-9B43-9CB3-3809-90EDECB61DA8}"/>
+              </a:ext>
+            </a:extLst>
+          </p:cNvPr>
+          <p:cNvPicPr>
+            <a:picLocks noChangeAspect="1"/>
+          </p:cNvPicPr>
+          <p:nvPr/>
+        </p:nvPicPr>
+        <p:blipFill>
+          <a:blip r:embed="rId2">
+            <a:extLst>
+              <a:ext uri="{28A0092B-C50C-407E-A947-70E740481C1C}">
+                <a14:useLocalDpi xmlns:a14="http://schemas.microsoft.com/office/drawing/2010/main" val="0"/>
+              </a:ext>
+            </a:extLst>
+          </a:blip>
+          <a:stretch>
+            <a:fillRect/>
+          </a:stretch>
+        </p:blipFill>
+        <p:spPr>
+          <a:xfrm>
+            <a:off x="11288700" y="103820"/>
+            <a:ext cx="812242" cy="1143636"/>
+          </a:xfrm>
+          <a:prstGeom prst="rect">
+            <a:avLst/>
+          </a:prstGeom>
+        </p:spPr>
+      </p:pic>
+      <p:sp>
+        <p:nvSpPr>
+          <p:cNvPr id="28" name="ZoneTexte 27">
+            <a:extLst>
+              <a:ext uri="{FF2B5EF4-FFF2-40B4-BE49-F238E27FC236}">
+                <a16:creationId xmlns:a16="http://schemas.microsoft.com/office/drawing/2014/main" id="{4D3EFCDC-EEB0-2DD2-2F79-A24BD69BF5A3}"/>
+              </a:ext>
+            </a:extLst>
+          </p:cNvPr>
+          <p:cNvSpPr txBox="1"/>
+          <p:nvPr/>
+        </p:nvSpPr>
+        <p:spPr>
+          <a:xfrm>
+            <a:off x="506304" y="5025934"/>
+            <a:ext cx="3670302" cy="451406"/>
+          </a:xfrm>
+          <a:prstGeom prst="rect">
+            <a:avLst/>
+          </a:prstGeom>
+          <a:noFill/>
+        </p:spPr>
+        <p:txBody>
+          <a:bodyPr wrap="square">
+            <a:spAutoFit/>
+          </a:bodyPr>
+          <a:lstStyle/>
+          <a:p>
+            <a:pPr marL="12700" algn="l">
+              <a:lnSpc>
+                <a:spcPts val="1415"/>
+              </a:lnSpc>
+              <a:tabLst>
+                <a:tab pos="3557904" algn="l"/>
+              </a:tabLst>
+            </a:pPr>
+            <a:r>
+              <a:rPr lang="fr-FR" sz="1400" b="1" spc="-40" dirty="0">
+                <a:solidFill>
+                  <a:srgbClr val="111111"/>
+                </a:solidFill>
+                <a:latin typeface="Arial"/>
+                <a:cs typeface="Arial"/>
+              </a:rPr>
+              <a:t>Des</a:t>
+            </a:r>
+            <a:r>
+              <a:rPr lang="fr-FR" sz="1400" b="1" spc="-90" dirty="0">
+                <a:solidFill>
+                  <a:srgbClr val="111111"/>
+                </a:solidFill>
+                <a:latin typeface="Arial"/>
+                <a:cs typeface="Arial"/>
+              </a:rPr>
+              <a:t> </a:t>
+            </a:r>
+            <a:r>
+              <a:rPr lang="fr-FR" sz="1400" b="1" spc="-60" dirty="0">
+                <a:solidFill>
+                  <a:srgbClr val="111111"/>
+                </a:solidFill>
+                <a:latin typeface="Arial"/>
+                <a:cs typeface="Arial"/>
+              </a:rPr>
+              <a:t>seuils</a:t>
+            </a:r>
+            <a:r>
+              <a:rPr lang="fr-FR" sz="1400" b="1" spc="-90" dirty="0">
+                <a:solidFill>
+                  <a:srgbClr val="111111"/>
+                </a:solidFill>
+                <a:latin typeface="Arial"/>
+                <a:cs typeface="Arial"/>
+              </a:rPr>
+              <a:t> </a:t>
+            </a:r>
+            <a:r>
+              <a:rPr lang="fr-FR" sz="1400" b="1" spc="-55" dirty="0">
+                <a:solidFill>
+                  <a:srgbClr val="111111"/>
+                </a:solidFill>
+                <a:latin typeface="Arial"/>
+                <a:cs typeface="Arial"/>
+              </a:rPr>
+              <a:t>explicites</a:t>
+            </a:r>
+            <a:r>
+              <a:rPr lang="fr-FR" sz="1400" b="1" spc="-70" dirty="0">
+                <a:solidFill>
+                  <a:srgbClr val="111111"/>
+                </a:solidFill>
+                <a:latin typeface="Arial"/>
+                <a:cs typeface="Arial"/>
+              </a:rPr>
+              <a:t> </a:t>
+            </a:r>
+            <a:r>
+              <a:rPr lang="fr-FR" sz="1400" spc="-30" dirty="0">
+                <a:solidFill>
+                  <a:srgbClr val="111111"/>
+                </a:solidFill>
+                <a:latin typeface="Arial MT"/>
+                <a:cs typeface="Arial MT"/>
+              </a:rPr>
+              <a:t>par</a:t>
+            </a:r>
+            <a:r>
+              <a:rPr lang="fr-FR" sz="1400" spc="-110" dirty="0">
+                <a:solidFill>
+                  <a:srgbClr val="111111"/>
+                </a:solidFill>
+                <a:latin typeface="Arial MT"/>
+                <a:cs typeface="Arial MT"/>
+              </a:rPr>
+              <a:t> </a:t>
+            </a:r>
+            <a:r>
+              <a:rPr lang="fr-FR" sz="1400" spc="-35" dirty="0">
+                <a:solidFill>
+                  <a:srgbClr val="111111"/>
+                </a:solidFill>
+                <a:latin typeface="Arial MT"/>
+                <a:cs typeface="Arial MT"/>
+              </a:rPr>
+              <a:t>capteur, </a:t>
+            </a:r>
+            <a:r>
+              <a:rPr lang="fr-FR" sz="1400" spc="-30" dirty="0">
+                <a:solidFill>
+                  <a:srgbClr val="111111"/>
+                </a:solidFill>
+                <a:latin typeface="Arial MT"/>
+                <a:cs typeface="Arial MT"/>
+              </a:rPr>
+              <a:t>avertissement</a:t>
+            </a:r>
+            <a:r>
+              <a:rPr lang="fr-FR" sz="1400" spc="-50" dirty="0">
+                <a:solidFill>
+                  <a:srgbClr val="111111"/>
+                </a:solidFill>
+                <a:latin typeface="Arial MT"/>
+                <a:cs typeface="Arial MT"/>
+              </a:rPr>
+              <a:t> </a:t>
+            </a:r>
+            <a:r>
+              <a:rPr lang="fr-FR" sz="1400" spc="-20" dirty="0">
+                <a:solidFill>
+                  <a:srgbClr val="111111"/>
+                </a:solidFill>
+                <a:latin typeface="Arial MT"/>
+                <a:cs typeface="Arial MT"/>
+              </a:rPr>
+              <a:t>puis</a:t>
+            </a:r>
+            <a:r>
+              <a:rPr lang="fr-FR" sz="1400" spc="-55" dirty="0">
+                <a:solidFill>
+                  <a:srgbClr val="111111"/>
+                </a:solidFill>
+                <a:latin typeface="Arial MT"/>
+                <a:cs typeface="Arial MT"/>
+              </a:rPr>
+              <a:t> </a:t>
+            </a:r>
+            <a:r>
+              <a:rPr lang="fr-FR" sz="1400" spc="-10" dirty="0">
+                <a:solidFill>
+                  <a:srgbClr val="111111"/>
+                </a:solidFill>
+                <a:latin typeface="Arial MT"/>
+                <a:cs typeface="Arial MT"/>
+              </a:rPr>
+              <a:t>critique.</a:t>
+            </a:r>
+            <a:endParaRPr lang="fr-FR" sz="1400" dirty="0">
+              <a:latin typeface="Arial MT"/>
+              <a:cs typeface="Arial MT"/>
+            </a:endParaRPr>
+          </a:p>
+        </p:txBody>
+      </p:sp>
+      <p:sp>
+        <p:nvSpPr>
+          <p:cNvPr id="30" name="ZoneTexte 29">
+            <a:extLst>
+              <a:ext uri="{FF2B5EF4-FFF2-40B4-BE49-F238E27FC236}">
+                <a16:creationId xmlns:a16="http://schemas.microsoft.com/office/drawing/2014/main" id="{8292370F-34CE-3552-7764-147EFE3A54CB}"/>
+              </a:ext>
+            </a:extLst>
+          </p:cNvPr>
+          <p:cNvSpPr txBox="1"/>
+          <p:nvPr/>
+        </p:nvSpPr>
+        <p:spPr>
+          <a:xfrm>
+            <a:off x="506304" y="2648108"/>
+            <a:ext cx="2541696" cy="323165"/>
+          </a:xfrm>
+          <a:prstGeom prst="rect">
+            <a:avLst/>
+          </a:prstGeom>
+          <a:noFill/>
+        </p:spPr>
+        <p:txBody>
+          <a:bodyPr wrap="square">
+            <a:spAutoFit/>
+          </a:bodyPr>
+          <a:lstStyle/>
+          <a:p>
+            <a:pPr algn="l" rtl="0"/>
+            <a:r>
+              <a:rPr lang="fr-FR" sz="1500" b="1" dirty="0">
+                <a:solidFill>
+                  <a:srgbClr val="111111"/>
+                </a:solidFill>
+                <a:latin typeface="Arial"/>
+                <a:cs typeface="Arial"/>
+              </a:rPr>
+              <a:t>Ingénieurs</a:t>
+            </a:r>
+            <a:r>
+              <a:rPr lang="fr-FR" sz="1500" b="1" spc="-125" dirty="0">
+                <a:solidFill>
+                  <a:srgbClr val="111111"/>
+                </a:solidFill>
+                <a:latin typeface="Arial"/>
+                <a:cs typeface="Arial"/>
+              </a:rPr>
+              <a:t> </a:t>
+            </a:r>
+            <a:r>
+              <a:rPr lang="fr-FR" sz="1500" b="1" dirty="0">
+                <a:solidFill>
+                  <a:srgbClr val="111111"/>
+                </a:solidFill>
+                <a:latin typeface="Arial"/>
+                <a:cs typeface="Arial"/>
+              </a:rPr>
+              <a:t>de</a:t>
+            </a:r>
+            <a:r>
+              <a:rPr lang="fr-FR" sz="1500" b="1" spc="-125" dirty="0">
+                <a:solidFill>
+                  <a:srgbClr val="111111"/>
+                </a:solidFill>
+                <a:latin typeface="Arial"/>
+                <a:cs typeface="Arial"/>
+              </a:rPr>
+              <a:t> </a:t>
+            </a:r>
+            <a:r>
+              <a:rPr lang="fr-FR" sz="1500" b="1" spc="-10" dirty="0">
+                <a:solidFill>
+                  <a:srgbClr val="111111"/>
+                </a:solidFill>
+                <a:latin typeface="Arial"/>
+                <a:cs typeface="Arial"/>
+              </a:rPr>
+              <a:t>production :</a:t>
+            </a:r>
+            <a:endParaRPr lang="fr-FR" dirty="0"/>
+          </a:p>
+        </p:txBody>
+      </p:sp>
+      <p:sp>
+        <p:nvSpPr>
+          <p:cNvPr id="32" name="ZoneTexte 31">
+            <a:extLst>
+              <a:ext uri="{FF2B5EF4-FFF2-40B4-BE49-F238E27FC236}">
+                <a16:creationId xmlns:a16="http://schemas.microsoft.com/office/drawing/2014/main" id="{003BD695-F388-7CC4-CF59-32402226AEA7}"/>
+              </a:ext>
+            </a:extLst>
+          </p:cNvPr>
+          <p:cNvSpPr txBox="1"/>
+          <p:nvPr/>
+        </p:nvSpPr>
+        <p:spPr>
+          <a:xfrm>
+            <a:off x="4308122" y="2648108"/>
+            <a:ext cx="2541696" cy="323165"/>
+          </a:xfrm>
+          <a:prstGeom prst="rect">
+            <a:avLst/>
+          </a:prstGeom>
+          <a:noFill/>
+        </p:spPr>
+        <p:txBody>
+          <a:bodyPr wrap="square">
+            <a:spAutoFit/>
+          </a:bodyPr>
+          <a:lstStyle/>
+          <a:p>
+            <a:pPr algn="l" rtl="0"/>
+            <a:r>
+              <a:rPr lang="fr-FR" sz="1500" b="1" spc="-10" dirty="0">
+                <a:solidFill>
+                  <a:srgbClr val="111111"/>
+                </a:solidFill>
+                <a:latin typeface="Arial"/>
+                <a:cs typeface="Arial"/>
+              </a:rPr>
+              <a:t>Équipes</a:t>
+            </a:r>
+            <a:r>
+              <a:rPr lang="fr-FR" sz="1500" b="1" spc="-120" dirty="0">
+                <a:solidFill>
+                  <a:srgbClr val="111111"/>
+                </a:solidFill>
+                <a:latin typeface="Arial"/>
+                <a:cs typeface="Arial"/>
+              </a:rPr>
+              <a:t> </a:t>
+            </a:r>
+            <a:r>
+              <a:rPr lang="fr-FR" sz="1500" b="1" dirty="0">
+                <a:solidFill>
+                  <a:srgbClr val="111111"/>
+                </a:solidFill>
+                <a:latin typeface="Arial"/>
+                <a:cs typeface="Arial"/>
+              </a:rPr>
+              <a:t>de</a:t>
+            </a:r>
+            <a:r>
+              <a:rPr lang="fr-FR" sz="1500" b="1" spc="-120" dirty="0">
+                <a:solidFill>
+                  <a:srgbClr val="111111"/>
+                </a:solidFill>
+                <a:latin typeface="Arial"/>
+                <a:cs typeface="Arial"/>
+              </a:rPr>
+              <a:t> </a:t>
+            </a:r>
+            <a:r>
+              <a:rPr lang="fr-FR" sz="1500" b="1" spc="-10" dirty="0">
+                <a:solidFill>
+                  <a:srgbClr val="111111"/>
+                </a:solidFill>
+                <a:latin typeface="Arial"/>
+                <a:cs typeface="Arial"/>
+              </a:rPr>
+              <a:t>maintenance :</a:t>
+            </a:r>
+            <a:endParaRPr lang="fr-FR" dirty="0"/>
           </a:p>
         </p:txBody>
       </p:sp>
@@ -6144,8 +5465,8 @@
         </p:nvSpPr>
         <p:spPr>
           <a:xfrm>
-            <a:off x="596899" y="208048"/>
-            <a:ext cx="5863590" cy="1143635"/>
+            <a:off x="596899" y="610664"/>
+            <a:ext cx="5863590" cy="548227"/>
           </a:xfrm>
           <a:prstGeom prst="rect">
             <a:avLst/>
@@ -6169,23 +5490,7 @@
               </a:tabLst>
             </a:pPr>
             <a:r>
-              <a:rPr sz="7300" spc="265" dirty="0">
-                <a:solidFill>
-                  <a:srgbClr val="1F36C7"/>
-                </a:solidFill>
-              </a:rPr>
-              <a:t>02</a:t>
-            </a:r>
-            <a:r>
-              <a:rPr sz="7300" dirty="0">
-                <a:solidFill>
-                  <a:srgbClr val="1F36C7"/>
-                </a:solidFill>
-              </a:rPr>
-              <a:t>	</a:t>
-            </a:r>
-            <a:r>
-              <a:rPr spc="-75" dirty="0"/>
+              <a:rPr spc="-75" dirty="0" err="1"/>
               <a:t>Besoins</a:t>
             </a:r>
             <a:r>
@@ -6196,7 +5501,7 @@
               <a:rPr spc="-30" dirty="0"/>
               <a:t>techniques</a:t>
             </a:r>
-            <a:endParaRPr sz="7300"/>
+            <a:endParaRPr sz="7300" dirty="0"/>
           </a:p>
         </p:txBody>
       </p:sp>
@@ -6295,7 +5600,7 @@
         <p:spPr>
           <a:xfrm>
             <a:off x="6197600" y="1655178"/>
-            <a:ext cx="2813050" cy="253365"/>
+            <a:ext cx="2813050" cy="242374"/>
           </a:xfrm>
           <a:prstGeom prst="rect">
             <a:avLst/>
@@ -6318,7 +5623,7 @@
             <a:r>
               <a:rPr sz="1500" b="1" dirty="0">
                 <a:solidFill>
-                  <a:srgbClr val="1F36C7"/>
+                  <a:srgbClr val="C00000"/>
                 </a:solidFill>
                 <a:latin typeface="Arial"/>
                 <a:cs typeface="Arial"/>
@@ -6328,7 +5633,7 @@
             <a:r>
               <a:rPr sz="1500" b="1" spc="-130" dirty="0">
                 <a:solidFill>
-                  <a:srgbClr val="1F36C7"/>
+                  <a:srgbClr val="C00000"/>
                 </a:solidFill>
                 <a:latin typeface="Arial"/>
                 <a:cs typeface="Arial"/>
@@ -6338,7 +5643,7 @@
             <a:r>
               <a:rPr sz="1500" b="1" spc="114" dirty="0">
                 <a:solidFill>
-                  <a:srgbClr val="1F36C7"/>
+                  <a:srgbClr val="C00000"/>
                 </a:solidFill>
                 <a:latin typeface="Arial"/>
                 <a:cs typeface="Arial"/>
@@ -6348,7 +5653,7 @@
             <a:r>
               <a:rPr sz="1500" b="1" spc="-195" dirty="0">
                 <a:solidFill>
-                  <a:srgbClr val="1F36C7"/>
+                  <a:srgbClr val="C00000"/>
                 </a:solidFill>
                 <a:latin typeface="Arial"/>
                 <a:cs typeface="Arial"/>
@@ -6358,7 +5663,7 @@
             <a:r>
               <a:rPr sz="1500" b="1" dirty="0">
                 <a:solidFill>
-                  <a:srgbClr val="1F36C7"/>
+                  <a:srgbClr val="C00000"/>
                 </a:solidFill>
                 <a:latin typeface="Arial"/>
                 <a:cs typeface="Arial"/>
@@ -6368,7 +5673,7 @@
             <a:r>
               <a:rPr sz="1500" b="1" spc="-185" dirty="0">
                 <a:solidFill>
-                  <a:srgbClr val="1F36C7"/>
+                  <a:srgbClr val="C00000"/>
                 </a:solidFill>
                 <a:latin typeface="Arial"/>
                 <a:cs typeface="Arial"/>
@@ -6378,7 +5683,7 @@
             <a:r>
               <a:rPr sz="1500" b="1" spc="50" dirty="0">
                 <a:solidFill>
-                  <a:srgbClr val="1F36C7"/>
+                  <a:srgbClr val="C00000"/>
                 </a:solidFill>
                 <a:latin typeface="Arial"/>
                 <a:cs typeface="Arial"/>
@@ -6388,7 +5693,7 @@
             <a:r>
               <a:rPr sz="1500" b="1" spc="-110" dirty="0">
                 <a:solidFill>
-                  <a:srgbClr val="1F36C7"/>
+                  <a:srgbClr val="C00000"/>
                 </a:solidFill>
                 <a:latin typeface="Arial"/>
                 <a:cs typeface="Arial"/>
@@ -6398,117 +5703,20 @@
             <a:r>
               <a:rPr sz="1500" b="1" spc="-10" dirty="0">
                 <a:solidFill>
-                  <a:srgbClr val="1F36C7"/>
+                  <a:srgbClr val="C00000"/>
                 </a:solidFill>
                 <a:latin typeface="Arial"/>
                 <a:cs typeface="Arial"/>
               </a:rPr>
               <a:t>sécuriser</a:t>
             </a:r>
-            <a:endParaRPr sz="1500">
+            <a:endParaRPr sz="1500" dirty="0">
+              <a:solidFill>
+                <a:srgbClr val="C00000"/>
+              </a:solidFill>
               <a:latin typeface="Arial"/>
               <a:cs typeface="Arial"/>
             </a:endParaRPr>
-          </a:p>
-        </p:txBody>
-      </p:sp>
-      <p:sp>
-        <p:nvSpPr>
-          <p:cNvPr id="3" name="object 3"/>
-          <p:cNvSpPr/>
-          <p:nvPr/>
-        </p:nvSpPr>
-        <p:spPr>
-          <a:xfrm>
-            <a:off x="609599" y="2009774"/>
-            <a:ext cx="5372100" cy="9525"/>
-          </a:xfrm>
-          <a:custGeom>
-            <a:avLst/>
-            <a:gdLst/>
-            <a:ahLst/>
-            <a:cxnLst/>
-            <a:rect l="l" t="t" r="r" b="b"/>
-            <a:pathLst>
-              <a:path w="5372100" h="9525">
-                <a:moveTo>
-                  <a:pt x="5372099" y="9524"/>
-                </a:moveTo>
-                <a:lnTo>
-                  <a:pt x="0" y="9524"/>
-                </a:lnTo>
-                <a:lnTo>
-                  <a:pt x="0" y="0"/>
-                </a:lnTo>
-                <a:lnTo>
-                  <a:pt x="5372099" y="0"/>
-                </a:lnTo>
-                <a:lnTo>
-                  <a:pt x="5372099" y="9524"/>
-                </a:lnTo>
-                <a:close/>
-              </a:path>
-            </a:pathLst>
-          </a:custGeom>
-          <a:solidFill>
-            <a:srgbClr val="111111"/>
-          </a:solidFill>
-        </p:spPr>
-        <p:txBody>
-          <a:bodyPr wrap="square" lIns="0" tIns="0" rIns="0" bIns="0" rtlCol="0"/>
-          <a:lstStyle/>
-          <a:p>
-            <a:endParaRPr/>
-          </a:p>
-        </p:txBody>
-      </p:sp>
-      <p:sp>
-        <p:nvSpPr>
-          <p:cNvPr id="6" name="object 6"/>
-          <p:cNvSpPr/>
-          <p:nvPr/>
-        </p:nvSpPr>
-        <p:spPr>
-          <a:xfrm>
-            <a:off x="6210299" y="2009774"/>
-            <a:ext cx="5372100" cy="9525"/>
-          </a:xfrm>
-          <a:custGeom>
-            <a:avLst/>
-            <a:gdLst/>
-            <a:ahLst/>
-            <a:cxnLst/>
-            <a:rect l="l" t="t" r="r" b="b"/>
-            <a:pathLst>
-              <a:path w="5372100" h="9525">
-                <a:moveTo>
-                  <a:pt x="5372099" y="9524"/>
-                </a:moveTo>
-                <a:lnTo>
-                  <a:pt x="0" y="9524"/>
-                </a:lnTo>
-                <a:lnTo>
-                  <a:pt x="0" y="0"/>
-                </a:lnTo>
-                <a:lnTo>
-                  <a:pt x="5372099" y="0"/>
-                </a:lnTo>
-                <a:lnTo>
-                  <a:pt x="5372099" y="9524"/>
-                </a:lnTo>
-                <a:close/>
-              </a:path>
-            </a:pathLst>
-          </a:custGeom>
-          <a:solidFill>
-            <a:srgbClr val="1F36C7"/>
-          </a:solidFill>
-        </p:spPr>
-        <p:txBody>
-          <a:bodyPr wrap="square" lIns="0" tIns="0" rIns="0" bIns="0" rtlCol="0"/>
-          <a:lstStyle/>
-          <a:p>
-            <a:endParaRPr/>
           </a:p>
         </p:txBody>
       </p:sp>
@@ -8168,11 +7376,17 @@
           <p:cNvGraphicFramePr>
             <a:graphicFrameLocks noGrp="1"/>
           </p:cNvGraphicFramePr>
-          <p:nvPr/>
+          <p:nvPr>
+            <p:extLst>
+              <p:ext uri="{D42A27DB-BD31-4B8C-83A1-F6EECF244321}">
+                <p14:modId xmlns:p14="http://schemas.microsoft.com/office/powerpoint/2010/main" val="189333335"/>
+              </p:ext>
+            </p:extLst>
+          </p:nvPr>
         </p:nvGraphicFramePr>
         <p:xfrm>
-          <a:off x="6210299" y="2153149"/>
-          <a:ext cx="5372733" cy="2496820"/>
+          <a:off x="6210299" y="2153148"/>
+          <a:ext cx="5372733" cy="2713988"/>
         </p:xfrm>
         <a:graphic>
           <a:graphicData uri="http://schemas.openxmlformats.org/drawingml/2006/table">
@@ -8203,7 +7417,7 @@
                   </a:extLst>
                 </a:gridCol>
               </a:tblGrid>
-              <a:tr h="241935">
+              <a:tr h="262978">
                 <a:tc>
                   <a:txBody>
                     <a:bodyPr/>
@@ -8315,7 +7529,7 @@
                   </a:ext>
                 </a:extLst>
               </a:tr>
-              <a:tr h="561340">
+              <a:tr h="610164">
                 <a:tc>
                   <a:txBody>
                     <a:bodyPr/>
@@ -8648,7 +7862,7 @@
                   </a:ext>
                 </a:extLst>
               </a:tr>
-              <a:tr h="280035">
+              <a:tr h="304392">
                 <a:tc>
                   <a:txBody>
                     <a:bodyPr/>
@@ -8859,7 +8073,7 @@
                   </a:ext>
                 </a:extLst>
               </a:tr>
-              <a:tr h="290830">
+              <a:tr h="316126">
                 <a:tc>
                   <a:txBody>
                     <a:bodyPr/>
@@ -9011,7 +8225,7 @@
                   </a:ext>
                 </a:extLst>
               </a:tr>
-              <a:tr h="561340">
+              <a:tr h="610164">
                 <a:tc>
                   <a:txBody>
                     <a:bodyPr/>
@@ -9340,7 +8554,7 @@
                   </a:ext>
                 </a:extLst>
               </a:tr>
-              <a:tr h="561340">
+              <a:tr h="610164">
                 <a:tc>
                   <a:txBody>
                     <a:bodyPr/>
@@ -9488,7 +8702,7 @@
                         </a:rPr>
                         <a:t>l’alerte muette</a:t>
                       </a:r>
-                      <a:endParaRPr sz="1300">
+                      <a:endParaRPr sz="1300" dirty="0">
                         <a:latin typeface="Arial MT"/>
                         <a:cs typeface="Arial MT"/>
                       </a:endParaRPr>
@@ -9592,7 +8806,7 @@
                         </a:rPr>
                         <a:t>code</a:t>
                       </a:r>
-                      <a:endParaRPr sz="1300">
+                      <a:endParaRPr sz="1300" dirty="0">
                         <a:latin typeface="Arial MT"/>
                         <a:cs typeface="Arial MT"/>
                       </a:endParaRPr>
@@ -9631,8 +8845,8 @@
         </p:nvSpPr>
         <p:spPr>
           <a:xfrm>
-            <a:off x="6197600" y="4785643"/>
-            <a:ext cx="5178425" cy="501650"/>
+            <a:off x="3506786" y="5334347"/>
+            <a:ext cx="5178425" cy="475323"/>
           </a:xfrm>
           <a:prstGeom prst="rect">
             <a:avLst/>
@@ -9644,7 +8858,7 @@
           </a:bodyPr>
           <a:lstStyle/>
           <a:p>
-            <a:pPr marL="12700" marR="5080">
+            <a:pPr marL="12700" marR="5080" algn="ctr">
               <a:lnSpc>
                 <a:spcPct val="111600"/>
               </a:lnSpc>
@@ -9882,7 +9096,7 @@
               </a:rPr>
               <a:t>commande.</a:t>
             </a:r>
-            <a:endParaRPr sz="1400">
+            <a:endParaRPr sz="1400" dirty="0">
               <a:latin typeface="Arial MT"/>
               <a:cs typeface="Arial MT"/>
             </a:endParaRPr>
@@ -9935,6 +9149,7 @@
           <a:bodyPr wrap="square" lIns="0" tIns="0" rIns="0" bIns="0" rtlCol="0"/>
           <a:lstStyle/>
           <a:p>
+            <a:pPr algn="l" rtl="0"/>
             <a:endParaRPr/>
           </a:p>
         </p:txBody>
@@ -10057,6 +9272,10 @@
           </p:nvPr>
         </p:nvSpPr>
         <p:spPr>
+          <a:xfrm>
+            <a:off x="596899" y="620676"/>
+            <a:ext cx="6407784" cy="548227"/>
+          </a:xfrm>
           <a:prstGeom prst="rect">
             <a:avLst/>
           </a:prstGeom>
@@ -10078,22 +9297,6 @@
                 <a:tab pos="1878964" algn="l"/>
               </a:tabLst>
             </a:pPr>
-            <a:r>
-              <a:rPr sz="7300" spc="290" dirty="0">
-                <a:solidFill>
-                  <a:srgbClr val="1F36C7"/>
-                </a:solidFill>
-              </a:rPr>
-              <a:t>03</a:t>
-            </a:r>
-            <a:r>
-              <a:rPr sz="7300" dirty="0">
-                <a:solidFill>
-                  <a:srgbClr val="1F36C7"/>
-                </a:solidFill>
-              </a:rPr>
-              <a:t>	</a:t>
-            </a:r>
             <a:r>
               <a:rPr spc="-45" dirty="0"/>
               <a:t>Architecture</a:t>
@@ -14953,7 +14156,7 @@
               </a:rPr>
               <a:t>Compose</a:t>
             </a:r>
-            <a:endParaRPr sz="1000">
+            <a:endParaRPr sz="1000" dirty="0">
               <a:latin typeface="Arial"/>
               <a:cs typeface="Arial"/>
             </a:endParaRPr>
@@ -14969,7 +14172,7 @@
         <p:spPr>
           <a:xfrm>
             <a:off x="7131049" y="1655178"/>
-            <a:ext cx="1906905" cy="253365"/>
+            <a:ext cx="1906905" cy="242374"/>
           </a:xfrm>
           <a:prstGeom prst="rect">
             <a:avLst/>
@@ -14992,7 +14195,7 @@
             <a:r>
               <a:rPr sz="1500" b="1" dirty="0">
                 <a:solidFill>
-                  <a:srgbClr val="1F36C7"/>
+                  <a:srgbClr val="C00000"/>
                 </a:solidFill>
                 <a:latin typeface="Arial"/>
                 <a:cs typeface="Arial"/>
@@ -15002,7 +14205,7 @@
             <a:r>
               <a:rPr sz="1500" b="1" spc="-60" dirty="0">
                 <a:solidFill>
-                  <a:srgbClr val="1F36C7"/>
+                  <a:srgbClr val="C00000"/>
                 </a:solidFill>
                 <a:latin typeface="Arial"/>
                 <a:cs typeface="Arial"/>
@@ -15012,14 +14215,17 @@
             <a:r>
               <a:rPr sz="1500" b="1" spc="-10" dirty="0">
                 <a:solidFill>
-                  <a:srgbClr val="1F36C7"/>
+                  <a:srgbClr val="C00000"/>
                 </a:solidFill>
                 <a:latin typeface="Arial"/>
                 <a:cs typeface="Arial"/>
               </a:rPr>
               <a:t>hybride</a:t>
             </a:r>
-            <a:endParaRPr sz="1500">
+            <a:endParaRPr sz="1500" dirty="0">
+              <a:solidFill>
+                <a:srgbClr val="C00000"/>
+              </a:solidFill>
               <a:latin typeface="Arial"/>
               <a:cs typeface="Arial"/>
             </a:endParaRPr>
@@ -23070,8 +22276,8 @@
         </p:nvSpPr>
         <p:spPr>
           <a:xfrm>
-            <a:off x="596899" y="208048"/>
-            <a:ext cx="6393815" cy="1143635"/>
+            <a:off x="596899" y="619127"/>
+            <a:ext cx="6393815" cy="548227"/>
           </a:xfrm>
           <a:prstGeom prst="rect">
             <a:avLst/>
@@ -23095,23 +22301,7 @@
               </a:tabLst>
             </a:pPr>
             <a:r>
-              <a:rPr sz="7300" spc="370" dirty="0">
-                <a:solidFill>
-                  <a:srgbClr val="1F36C7"/>
-                </a:solidFill>
-              </a:rPr>
-              <a:t>04</a:t>
-            </a:r>
-            <a:r>
-              <a:rPr sz="7300" dirty="0">
-                <a:solidFill>
-                  <a:srgbClr val="1F36C7"/>
-                </a:solidFill>
-              </a:rPr>
-              <a:t>	</a:t>
-            </a:r>
-            <a:r>
-              <a:rPr spc="-75" dirty="0"/>
+              <a:rPr spc="-75" dirty="0" err="1"/>
               <a:t>Risques</a:t>
             </a:r>
             <a:r>
@@ -23130,7 +22320,7 @@
               <a:rPr spc="-10" dirty="0"/>
               <a:t>atténuation</a:t>
             </a:r>
-            <a:endParaRPr sz="7300"/>
+            <a:endParaRPr sz="7300" dirty="0"/>
           </a:p>
         </p:txBody>
       </p:sp>
@@ -23140,7 +22330,13 @@
           <p:cNvGraphicFramePr>
             <a:graphicFrameLocks noGrp="1"/>
           </p:cNvGraphicFramePr>
-          <p:nvPr/>
+          <p:nvPr>
+            <p:extLst>
+              <p:ext uri="{D42A27DB-BD31-4B8C-83A1-F6EECF244321}">
+                <p14:modId xmlns:p14="http://schemas.microsoft.com/office/powerpoint/2010/main" val="2772889881"/>
+              </p:ext>
+            </p:extLst>
+          </p:nvPr>
         </p:nvGraphicFramePr>
         <p:xfrm>
           <a:off x="609599" y="1714999"/>
@@ -23266,7 +22462,7 @@
                       <a:r>
                         <a:rPr sz="1150" b="1" dirty="0">
                           <a:solidFill>
-                            <a:srgbClr val="1F36C7"/>
+                            <a:srgbClr val="C00000"/>
                           </a:solidFill>
                           <a:latin typeface="Arial"/>
                           <a:cs typeface="Arial"/>
@@ -23276,7 +22472,7 @@
                       <a:r>
                         <a:rPr sz="1150" b="1" spc="-50" dirty="0">
                           <a:solidFill>
-                            <a:srgbClr val="1F36C7"/>
+                            <a:srgbClr val="C00000"/>
                           </a:solidFill>
                           <a:latin typeface="Arial"/>
                           <a:cs typeface="Arial"/>
@@ -23286,7 +22482,7 @@
                       <a:r>
                         <a:rPr sz="1150" b="1" dirty="0">
                           <a:solidFill>
-                            <a:srgbClr val="1F36C7"/>
+                            <a:srgbClr val="C00000"/>
                           </a:solidFill>
                           <a:latin typeface="Arial"/>
                           <a:cs typeface="Arial"/>
@@ -23296,7 +22492,7 @@
                       <a:r>
                         <a:rPr sz="1150" b="1" spc="-55" dirty="0">
                           <a:solidFill>
-                            <a:srgbClr val="1F36C7"/>
+                            <a:srgbClr val="C00000"/>
                           </a:solidFill>
                           <a:latin typeface="Arial"/>
                           <a:cs typeface="Arial"/>
@@ -23306,14 +22502,17 @@
                       <a:r>
                         <a:rPr sz="1150" b="1" spc="-10" dirty="0">
                           <a:solidFill>
-                            <a:srgbClr val="1F36C7"/>
+                            <a:srgbClr val="C00000"/>
                           </a:solidFill>
                           <a:latin typeface="Arial"/>
                           <a:cs typeface="Arial"/>
                         </a:rPr>
                         <a:t>prototype</a:t>
                       </a:r>
-                      <a:endParaRPr sz="1150">
+                      <a:endParaRPr sz="1150" dirty="0">
+                        <a:solidFill>
+                          <a:srgbClr val="C00000"/>
+                        </a:solidFill>
                         <a:latin typeface="Arial"/>
                         <a:cs typeface="Arial"/>
                       </a:endParaRPr>
@@ -26364,7 +25563,7 @@
                         </a:rPr>
                         <a:t>redondant</a:t>
                       </a:r>
-                      <a:endParaRPr sz="1300">
+                      <a:endParaRPr sz="1300" dirty="0">
                         <a:latin typeface="Arial MT"/>
                         <a:cs typeface="Arial MT"/>
                       </a:endParaRPr>

</xml_diff>

<commit_message>
feat(presentation): update slides for project overview
</commit_message>
<xml_diff>
--- a/presentation/slides.pptx
+++ b/presentation/slides.pptx
@@ -2286,7 +2286,7 @@
         <p:spPr>
           <a:xfrm>
             <a:off x="596899" y="1641230"/>
-            <a:ext cx="6946265" cy="711092"/>
+            <a:ext cx="11000224" cy="711092"/>
           </a:xfrm>
           <a:prstGeom prst="rect">
             <a:avLst/>
@@ -2307,7 +2307,7 @@
               </a:spcBef>
             </a:pPr>
             <a:r>
-              <a:rPr sz="2350" b="1" spc="-140" dirty="0">
+              <a:rPr sz="2400" b="1" spc="-140" dirty="0">
                 <a:solidFill>
                   <a:srgbClr val="111111"/>
                 </a:solidFill>
@@ -2317,7 +2317,7 @@
               <a:t>Voir</a:t>
             </a:r>
             <a:r>
-              <a:rPr sz="2350" b="1" spc="-330" dirty="0">
+              <a:rPr sz="2400" b="1" spc="-330" dirty="0">
                 <a:solidFill>
                   <a:srgbClr val="111111"/>
                 </a:solidFill>
@@ -2327,7 +2327,7 @@
               <a:t> </a:t>
             </a:r>
             <a:r>
-              <a:rPr sz="2350" b="1" spc="-125" dirty="0">
+              <a:rPr sz="2400" b="1" spc="-125" dirty="0">
                 <a:solidFill>
                   <a:srgbClr val="111111"/>
                 </a:solidFill>
@@ -2337,7 +2337,7 @@
               <a:t>une</a:t>
             </a:r>
             <a:r>
-              <a:rPr sz="2350" b="1" spc="-260" dirty="0">
+              <a:rPr sz="2400" b="1" spc="-260" dirty="0">
                 <a:solidFill>
                   <a:srgbClr val="111111"/>
                 </a:solidFill>
@@ -2347,7 +2347,7 @@
               <a:t> </a:t>
             </a:r>
             <a:r>
-              <a:rPr sz="2350" b="1" spc="-135" dirty="0">
+              <a:rPr sz="2400" b="1" spc="-135" dirty="0">
                 <a:solidFill>
                   <a:srgbClr val="111111"/>
                 </a:solidFill>
@@ -2357,7 +2357,7 @@
               <a:t>machine</a:t>
             </a:r>
             <a:r>
-              <a:rPr sz="2350" b="1" spc="-254" dirty="0">
+              <a:rPr sz="2400" b="1" spc="-254" dirty="0">
                 <a:solidFill>
                   <a:srgbClr val="111111"/>
                 </a:solidFill>
@@ -2367,7 +2367,7 @@
               <a:t> </a:t>
             </a:r>
             <a:r>
-              <a:rPr sz="2350" b="1" spc="-120" dirty="0">
+              <a:rPr sz="2400" b="1" spc="-120" dirty="0">
                 <a:solidFill>
                   <a:srgbClr val="111111"/>
                 </a:solidFill>
@@ -2377,7 +2377,7 @@
               <a:t>dériver</a:t>
             </a:r>
             <a:r>
-              <a:rPr sz="2350" b="1" spc="-330" dirty="0">
+              <a:rPr sz="2400" b="1" spc="-330" dirty="0">
                 <a:solidFill>
                   <a:srgbClr val="111111"/>
                 </a:solidFill>
@@ -2387,7 +2387,7 @@
               <a:t> </a:t>
             </a:r>
             <a:r>
-              <a:rPr sz="2350" b="1" spc="-130" dirty="0">
+              <a:rPr sz="2400" b="1" spc="-130" dirty="0">
                 <a:solidFill>
                   <a:srgbClr val="111111"/>
                 </a:solidFill>
@@ -2397,7 +2397,7 @@
               <a:t>avant</a:t>
             </a:r>
             <a:r>
-              <a:rPr sz="2350" b="1" spc="-240" dirty="0">
+              <a:rPr sz="2400" b="1" spc="-240" dirty="0">
                 <a:solidFill>
                   <a:srgbClr val="111111"/>
                 </a:solidFill>
@@ -2407,7 +2407,7 @@
               <a:t> </a:t>
             </a:r>
             <a:r>
-              <a:rPr sz="2350" b="1" spc="-130" dirty="0">
+              <a:rPr sz="2400" b="1" spc="-130" dirty="0">
                 <a:solidFill>
                   <a:srgbClr val="111111"/>
                 </a:solidFill>
@@ -2417,7 +2417,7 @@
               <a:t>qu’elle</a:t>
             </a:r>
             <a:r>
-              <a:rPr sz="2350" b="1" spc="-254" dirty="0">
+              <a:rPr sz="2400" b="1" spc="-254" dirty="0">
                 <a:solidFill>
                   <a:srgbClr val="111111"/>
                 </a:solidFill>
@@ -2427,7 +2427,7 @@
               <a:t> </a:t>
             </a:r>
             <a:r>
-              <a:rPr sz="2350" b="1" spc="-130" dirty="0">
+              <a:rPr sz="2400" b="1" spc="-130" dirty="0">
                 <a:solidFill>
                   <a:srgbClr val="111111"/>
                 </a:solidFill>
@@ -2437,7 +2437,7 @@
               <a:t>tombe</a:t>
             </a:r>
             <a:r>
-              <a:rPr sz="2350" b="1" spc="-260" dirty="0">
+              <a:rPr sz="2400" b="1" spc="-260" dirty="0">
                 <a:solidFill>
                   <a:srgbClr val="111111"/>
                 </a:solidFill>
@@ -2447,7 +2447,7 @@
               <a:t> </a:t>
             </a:r>
             <a:r>
-              <a:rPr sz="2350" b="1" spc="-125" dirty="0">
+              <a:rPr sz="2400" b="1" spc="-125" dirty="0">
                 <a:solidFill>
                   <a:srgbClr val="111111"/>
                 </a:solidFill>
@@ -2457,7 +2457,7 @@
               <a:t>en</a:t>
             </a:r>
             <a:r>
-              <a:rPr sz="2350" b="1" spc="-195" dirty="0">
+              <a:rPr sz="2400" b="1" spc="-195" dirty="0">
                 <a:solidFill>
                   <a:srgbClr val="111111"/>
                 </a:solidFill>
@@ -2467,7 +2467,7 @@
               <a:t> </a:t>
             </a:r>
             <a:r>
-              <a:rPr sz="2350" b="1" spc="-110" dirty="0">
+              <a:rPr sz="2400" b="1" spc="-110" dirty="0">
                 <a:solidFill>
                   <a:srgbClr val="111111"/>
                 </a:solidFill>
@@ -2477,7 +2477,7 @@
               <a:t>panne, </a:t>
             </a:r>
             <a:r>
-              <a:rPr sz="2350" b="1" spc="-80" dirty="0">
+              <a:rPr sz="2400" b="1" spc="-80" dirty="0">
                 <a:solidFill>
                   <a:srgbClr val="111111"/>
                 </a:solidFill>
@@ -2487,7 +2487,7 @@
               <a:t>et</a:t>
             </a:r>
             <a:r>
-              <a:rPr sz="2350" b="1" spc="-250" dirty="0">
+              <a:rPr sz="2400" b="1" spc="-250" dirty="0">
                 <a:solidFill>
                   <a:srgbClr val="111111"/>
                 </a:solidFill>
@@ -2497,7 +2497,7 @@
               <a:t> </a:t>
             </a:r>
             <a:r>
-              <a:rPr sz="2350" b="1" spc="-140" dirty="0">
+              <a:rPr sz="2400" b="1" spc="-140" dirty="0">
                 <a:solidFill>
                   <a:srgbClr val="111111"/>
                 </a:solidFill>
@@ -2507,7 +2507,7 @@
               <a:t>prouver</a:t>
             </a:r>
             <a:r>
-              <a:rPr sz="2350" b="1" spc="-335" dirty="0">
+              <a:rPr sz="2400" b="1" spc="-335" dirty="0">
                 <a:solidFill>
                   <a:srgbClr val="111111"/>
                 </a:solidFill>
@@ -2517,7 +2517,7 @@
               <a:t> </a:t>
             </a:r>
             <a:r>
-              <a:rPr sz="2350" b="1" spc="-120" dirty="0">
+              <a:rPr sz="2400" b="1" spc="-120" dirty="0">
                 <a:solidFill>
                   <a:srgbClr val="111111"/>
                 </a:solidFill>
@@ -2527,7 +2527,7 @@
               <a:t>que</a:t>
             </a:r>
             <a:r>
-              <a:rPr sz="2350" b="1" spc="-265" dirty="0">
+              <a:rPr sz="2400" b="1" spc="-265" dirty="0">
                 <a:solidFill>
                   <a:srgbClr val="111111"/>
                 </a:solidFill>
@@ -2537,7 +2537,7 @@
               <a:t> </a:t>
             </a:r>
             <a:r>
-              <a:rPr sz="2350" b="1" spc="-125" dirty="0">
+              <a:rPr sz="2400" b="1" spc="-125" dirty="0">
                 <a:solidFill>
                   <a:srgbClr val="111111"/>
                 </a:solidFill>
@@ -2547,7 +2547,7 @@
               <a:t>chaque</a:t>
             </a:r>
             <a:r>
-              <a:rPr sz="2350" b="1" spc="-265" dirty="0">
+              <a:rPr sz="2400" b="1" spc="-265" dirty="0">
                 <a:solidFill>
                   <a:srgbClr val="111111"/>
                 </a:solidFill>
@@ -2557,7 +2557,7 @@
               <a:t> </a:t>
             </a:r>
             <a:r>
-              <a:rPr sz="2350" b="1" spc="-105" dirty="0">
+              <a:rPr sz="2400" b="1" spc="-105" dirty="0">
                 <a:solidFill>
                   <a:srgbClr val="111111"/>
                 </a:solidFill>
@@ -2567,7 +2567,7 @@
               <a:t>alerte</a:t>
             </a:r>
             <a:r>
-              <a:rPr sz="2350" b="1" spc="-265" dirty="0">
+              <a:rPr sz="2400" b="1" spc="-265" dirty="0">
                 <a:solidFill>
                   <a:srgbClr val="111111"/>
                 </a:solidFill>
@@ -2577,7 +2577,7 @@
               <a:t> </a:t>
             </a:r>
             <a:r>
-              <a:rPr sz="2350" b="1" dirty="0">
+              <a:rPr sz="2400" b="1" dirty="0">
                 <a:solidFill>
                   <a:srgbClr val="111111"/>
                 </a:solidFill>
@@ -2587,7 +2587,7 @@
               <a:t>a</a:t>
             </a:r>
             <a:r>
-              <a:rPr sz="2350" b="1" spc="-360" dirty="0">
+              <a:rPr sz="2400" b="1" spc="-360" dirty="0">
                 <a:solidFill>
                   <a:srgbClr val="111111"/>
                 </a:solidFill>
@@ -2597,7 +2597,7 @@
               <a:t> </a:t>
             </a:r>
             <a:r>
-              <a:rPr sz="2350" b="1" spc="-85" dirty="0">
+              <a:rPr sz="2400" b="1" spc="-85" dirty="0">
                 <a:solidFill>
                   <a:srgbClr val="111111"/>
                 </a:solidFill>
@@ -2607,7 +2607,7 @@
               <a:t>été</a:t>
             </a:r>
             <a:r>
-              <a:rPr sz="2350" b="1" spc="-265" dirty="0">
+              <a:rPr sz="2400" b="1" spc="-265" dirty="0">
                 <a:solidFill>
                   <a:srgbClr val="111111"/>
                 </a:solidFill>
@@ -2617,7 +2617,7 @@
               <a:t> </a:t>
             </a:r>
             <a:r>
-              <a:rPr sz="2350" b="1" spc="-120" dirty="0">
+              <a:rPr sz="2400" b="1" spc="-120" dirty="0">
                 <a:solidFill>
                   <a:srgbClr val="111111"/>
                 </a:solidFill>
@@ -2627,7 +2627,7 @@
               <a:t>prise</a:t>
             </a:r>
             <a:r>
-              <a:rPr sz="2350" b="1" spc="-265" dirty="0">
+              <a:rPr sz="2400" b="1" spc="-265" dirty="0">
                 <a:solidFill>
                   <a:srgbClr val="111111"/>
                 </a:solidFill>
@@ -2637,7 +2637,7 @@
               <a:t> </a:t>
             </a:r>
             <a:r>
-              <a:rPr sz="2350" b="1" spc="-125" dirty="0">
+              <a:rPr sz="2400" b="1" spc="-125" dirty="0">
                 <a:solidFill>
                   <a:srgbClr val="111111"/>
                 </a:solidFill>
@@ -2647,7 +2647,7 @@
               <a:t>en</a:t>
             </a:r>
             <a:r>
-              <a:rPr sz="2350" b="1" spc="-204" dirty="0">
+              <a:rPr sz="2400" b="1" spc="-204" dirty="0">
                 <a:solidFill>
                   <a:srgbClr val="111111"/>
                 </a:solidFill>
@@ -2657,7 +2657,7 @@
               <a:t> </a:t>
             </a:r>
             <a:r>
-              <a:rPr sz="2350" b="1" spc="-10" dirty="0">
+              <a:rPr sz="2400" b="1" spc="-10" dirty="0">
                 <a:solidFill>
                   <a:srgbClr val="111111"/>
                 </a:solidFill>
@@ -2666,7 +2666,7 @@
               </a:rPr>
               <a:t>charge.</a:t>
             </a:r>
-            <a:endParaRPr sz="2350" dirty="0">
+            <a:endParaRPr sz="2400" dirty="0">
               <a:latin typeface="Arial"/>
               <a:cs typeface="Arial"/>
             </a:endParaRPr>
@@ -2682,7 +2682,7 @@
         <p:spPr>
           <a:xfrm>
             <a:off x="8064499" y="2674353"/>
-            <a:ext cx="2070101" cy="242374"/>
+            <a:ext cx="2070101" cy="257763"/>
           </a:xfrm>
           <a:prstGeom prst="rect">
             <a:avLst/>
@@ -2703,7 +2703,7 @@
               </a:spcBef>
             </a:pPr>
             <a:r>
-              <a:rPr sz="1500" b="1" dirty="0" err="1">
+              <a:rPr sz="1600" b="1" dirty="0" err="1">
                 <a:solidFill>
                   <a:srgbClr val="C00000"/>
                 </a:solidFill>
@@ -2713,7 +2713,7 @@
               <a:t>Bénéfices</a:t>
             </a:r>
             <a:r>
-              <a:rPr sz="1500" b="1" spc="-35" dirty="0">
+              <a:rPr sz="1600" b="1" spc="-35" dirty="0">
                 <a:solidFill>
                   <a:srgbClr val="C00000"/>
                 </a:solidFill>
@@ -2723,7 +2723,7 @@
               <a:t> </a:t>
             </a:r>
             <a:r>
-              <a:rPr sz="1500" b="1" spc="-10" dirty="0" err="1">
+              <a:rPr sz="1600" b="1" spc="-10" dirty="0" err="1">
                 <a:solidFill>
                   <a:srgbClr val="C00000"/>
                 </a:solidFill>
@@ -2733,7 +2733,7 @@
               <a:t>attendus</a:t>
             </a:r>
             <a:r>
-              <a:rPr lang="fr-FR" sz="1500" b="1" spc="-10" dirty="0">
+              <a:rPr lang="fr-FR" sz="1600" b="1" spc="-10" dirty="0">
                 <a:solidFill>
                   <a:srgbClr val="C00000"/>
                 </a:solidFill>
@@ -2742,7 +2742,7 @@
               </a:rPr>
               <a:t> :</a:t>
             </a:r>
-            <a:endParaRPr sz="1500" dirty="0">
+            <a:endParaRPr sz="1600" dirty="0">
               <a:solidFill>
                 <a:srgbClr val="C00000"/>
               </a:solidFill>
@@ -5277,7 +5277,7 @@
         <p:spPr>
           <a:xfrm>
             <a:off x="506304" y="2648108"/>
-            <a:ext cx="2541696" cy="323165"/>
+            <a:ext cx="2770296" cy="338554"/>
           </a:xfrm>
           <a:prstGeom prst="rect">
             <a:avLst/>
@@ -5292,9 +5292,9 @@
           <a:p>
             <a:pPr algn="l" rtl="0"/>
             <a:r>
-              <a:rPr lang="fr-FR" sz="1500" b="1" dirty="0">
-                <a:solidFill>
-                  <a:srgbClr val="111111"/>
+              <a:rPr lang="fr-FR" sz="1600" b="1" dirty="0">
+                <a:solidFill>
+                  <a:srgbClr val="C00000"/>
                 </a:solidFill>
                 <a:latin typeface="Arial"/>
                 <a:cs typeface="Arial"/>
@@ -5302,9 +5302,9 @@
               <a:t>Ingénieurs</a:t>
             </a:r>
             <a:r>
-              <a:rPr lang="fr-FR" sz="1500" b="1" spc="-125" dirty="0">
-                <a:solidFill>
-                  <a:srgbClr val="111111"/>
+              <a:rPr lang="fr-FR" sz="1600" b="1" spc="-125" dirty="0">
+                <a:solidFill>
+                  <a:srgbClr val="C00000"/>
                 </a:solidFill>
                 <a:latin typeface="Arial"/>
                 <a:cs typeface="Arial"/>
@@ -5312,9 +5312,9 @@
               <a:t> </a:t>
             </a:r>
             <a:r>
-              <a:rPr lang="fr-FR" sz="1500" b="1" dirty="0">
-                <a:solidFill>
-                  <a:srgbClr val="111111"/>
+              <a:rPr lang="fr-FR" sz="1600" b="1" dirty="0">
+                <a:solidFill>
+                  <a:srgbClr val="C00000"/>
                 </a:solidFill>
                 <a:latin typeface="Arial"/>
                 <a:cs typeface="Arial"/>
@@ -5322,9 +5322,9 @@
               <a:t>de</a:t>
             </a:r>
             <a:r>
-              <a:rPr lang="fr-FR" sz="1500" b="1" spc="-125" dirty="0">
-                <a:solidFill>
-                  <a:srgbClr val="111111"/>
+              <a:rPr lang="fr-FR" sz="1600" b="1" spc="-125" dirty="0">
+                <a:solidFill>
+                  <a:srgbClr val="C00000"/>
                 </a:solidFill>
                 <a:latin typeface="Arial"/>
                 <a:cs typeface="Arial"/>
@@ -5332,16 +5332,20 @@
               <a:t> </a:t>
             </a:r>
             <a:r>
-              <a:rPr lang="fr-FR" sz="1500" b="1" spc="-10" dirty="0">
-                <a:solidFill>
-                  <a:srgbClr val="111111"/>
+              <a:rPr lang="fr-FR" sz="1600" b="1" spc="-10" dirty="0">
+                <a:solidFill>
+                  <a:srgbClr val="C00000"/>
                 </a:solidFill>
                 <a:latin typeface="Arial"/>
                 <a:cs typeface="Arial"/>
               </a:rPr>
               <a:t>production :</a:t>
             </a:r>
-            <a:endParaRPr lang="fr-FR" dirty="0"/>
+            <a:endParaRPr lang="fr-FR" sz="2000" dirty="0">
+              <a:solidFill>
+                <a:srgbClr val="C00000"/>
+              </a:solidFill>
+            </a:endParaRPr>
           </a:p>
         </p:txBody>
       </p:sp>
@@ -5360,7 +5364,7 @@
         <p:spPr>
           <a:xfrm>
             <a:off x="4308122" y="2648108"/>
-            <a:ext cx="2541696" cy="323165"/>
+            <a:ext cx="2770296" cy="338554"/>
           </a:xfrm>
           <a:prstGeom prst="rect">
             <a:avLst/>
@@ -5375,9 +5379,9 @@
           <a:p>
             <a:pPr algn="l" rtl="0"/>
             <a:r>
-              <a:rPr lang="fr-FR" sz="1500" b="1" spc="-10" dirty="0">
-                <a:solidFill>
-                  <a:srgbClr val="111111"/>
+              <a:rPr lang="fr-FR" sz="1600" b="1" spc="-10" dirty="0">
+                <a:solidFill>
+                  <a:srgbClr val="C00000"/>
                 </a:solidFill>
                 <a:latin typeface="Arial"/>
                 <a:cs typeface="Arial"/>
@@ -5385,9 +5389,9 @@
               <a:t>Équipes</a:t>
             </a:r>
             <a:r>
-              <a:rPr lang="fr-FR" sz="1500" b="1" spc="-120" dirty="0">
-                <a:solidFill>
-                  <a:srgbClr val="111111"/>
+              <a:rPr lang="fr-FR" sz="1600" b="1" spc="-120" dirty="0">
+                <a:solidFill>
+                  <a:srgbClr val="C00000"/>
                 </a:solidFill>
                 <a:latin typeface="Arial"/>
                 <a:cs typeface="Arial"/>
@@ -5395,9 +5399,9 @@
               <a:t> </a:t>
             </a:r>
             <a:r>
-              <a:rPr lang="fr-FR" sz="1500" b="1" dirty="0">
-                <a:solidFill>
-                  <a:srgbClr val="111111"/>
+              <a:rPr lang="fr-FR" sz="1600" b="1" dirty="0">
+                <a:solidFill>
+                  <a:srgbClr val="C00000"/>
                 </a:solidFill>
                 <a:latin typeface="Arial"/>
                 <a:cs typeface="Arial"/>
@@ -5405,9 +5409,9 @@
               <a:t>de</a:t>
             </a:r>
             <a:r>
-              <a:rPr lang="fr-FR" sz="1500" b="1" spc="-120" dirty="0">
-                <a:solidFill>
-                  <a:srgbClr val="111111"/>
+              <a:rPr lang="fr-FR" sz="1600" b="1" spc="-120" dirty="0">
+                <a:solidFill>
+                  <a:srgbClr val="C00000"/>
                 </a:solidFill>
                 <a:latin typeface="Arial"/>
                 <a:cs typeface="Arial"/>
@@ -5415,16 +5419,20 @@
               <a:t> </a:t>
             </a:r>
             <a:r>
-              <a:rPr lang="fr-FR" sz="1500" b="1" spc="-10" dirty="0">
-                <a:solidFill>
-                  <a:srgbClr val="111111"/>
+              <a:rPr lang="fr-FR" sz="1600" b="1" spc="-10" dirty="0">
+                <a:solidFill>
+                  <a:srgbClr val="C00000"/>
                 </a:solidFill>
                 <a:latin typeface="Arial"/>
                 <a:cs typeface="Arial"/>
               </a:rPr>
               <a:t>maintenance :</a:t>
             </a:r>
-            <a:endParaRPr lang="fr-FR" dirty="0"/>
+            <a:endParaRPr lang="fr-FR" sz="2000" dirty="0">
+              <a:solidFill>
+                <a:srgbClr val="C00000"/>
+              </a:solidFill>
+            </a:endParaRPr>
           </a:p>
         </p:txBody>
       </p:sp>
@@ -5513,8 +5521,8 @@
         </p:nvSpPr>
         <p:spPr>
           <a:xfrm>
-            <a:off x="596899" y="1655178"/>
-            <a:ext cx="2030095" cy="253365"/>
+            <a:off x="596899" y="1738826"/>
+            <a:ext cx="2030095" cy="242374"/>
           </a:xfrm>
           <a:prstGeom prst="rect">
             <a:avLst/>
@@ -5537,7 +5545,7 @@
             <a:r>
               <a:rPr sz="1500" b="1" dirty="0">
                 <a:solidFill>
-                  <a:srgbClr val="111111"/>
+                  <a:srgbClr val="C00000"/>
                 </a:solidFill>
                 <a:latin typeface="Arial"/>
                 <a:cs typeface="Arial"/>
@@ -5547,7 +5555,7 @@
             <a:r>
               <a:rPr sz="1500" b="1" spc="-125" dirty="0">
                 <a:solidFill>
-                  <a:srgbClr val="111111"/>
+                  <a:srgbClr val="C00000"/>
                 </a:solidFill>
                 <a:latin typeface="Arial"/>
                 <a:cs typeface="Arial"/>
@@ -5557,7 +5565,7 @@
             <a:r>
               <a:rPr sz="1500" b="1" spc="114" dirty="0">
                 <a:solidFill>
-                  <a:srgbClr val="111111"/>
+                  <a:srgbClr val="C00000"/>
                 </a:solidFill>
                 <a:latin typeface="Arial"/>
                 <a:cs typeface="Arial"/>
@@ -5567,7 +5575,7 @@
             <a:r>
               <a:rPr sz="1500" b="1" spc="-190" dirty="0">
                 <a:solidFill>
-                  <a:srgbClr val="111111"/>
+                  <a:srgbClr val="C00000"/>
                 </a:solidFill>
                 <a:latin typeface="Arial"/>
                 <a:cs typeface="Arial"/>
@@ -5577,14 +5585,17 @@
             <a:r>
               <a:rPr sz="1500" b="1" spc="-10" dirty="0">
                 <a:solidFill>
-                  <a:srgbClr val="111111"/>
+                  <a:srgbClr val="C00000"/>
                 </a:solidFill>
                 <a:latin typeface="Arial"/>
                 <a:cs typeface="Arial"/>
               </a:rPr>
               <a:t>développer</a:t>
             </a:r>
-            <a:endParaRPr sz="1500">
+            <a:endParaRPr sz="1500" dirty="0">
+              <a:solidFill>
+                <a:srgbClr val="C00000"/>
+              </a:solidFill>
               <a:latin typeface="Arial"/>
               <a:cs typeface="Arial"/>
             </a:endParaRPr>
@@ -5599,7 +5610,7 @@
         </p:nvSpPr>
         <p:spPr>
           <a:xfrm>
-            <a:off x="6197600" y="1655178"/>
+            <a:off x="6197600" y="1738826"/>
             <a:ext cx="2813050" cy="242374"/>
           </a:xfrm>
           <a:prstGeom prst="rect">
@@ -5726,10 +5737,16 @@
           <p:cNvGraphicFramePr>
             <a:graphicFrameLocks noGrp="1"/>
           </p:cNvGraphicFramePr>
-          <p:nvPr/>
+          <p:nvPr>
+            <p:extLst>
+              <p:ext uri="{D42A27DB-BD31-4B8C-83A1-F6EECF244321}">
+                <p14:modId xmlns:p14="http://schemas.microsoft.com/office/powerpoint/2010/main" val="2609574426"/>
+              </p:ext>
+            </p:extLst>
+          </p:nvPr>
         </p:nvGraphicFramePr>
         <p:xfrm>
-          <a:off x="609599" y="2153149"/>
+          <a:off x="609599" y="2315210"/>
           <a:ext cx="5371464" cy="2713990"/>
         </p:xfrm>
         <a:graphic>
@@ -7379,13 +7396,13 @@
           <p:nvPr>
             <p:extLst>
               <p:ext uri="{D42A27DB-BD31-4B8C-83A1-F6EECF244321}">
-                <p14:modId xmlns:p14="http://schemas.microsoft.com/office/powerpoint/2010/main" val="189333335"/>
+                <p14:modId xmlns:p14="http://schemas.microsoft.com/office/powerpoint/2010/main" val="3765333822"/>
               </p:ext>
             </p:extLst>
           </p:nvPr>
         </p:nvGraphicFramePr>
         <p:xfrm>
-          <a:off x="6210299" y="2153148"/>
+          <a:off x="6210299" y="2315209"/>
           <a:ext cx="5372733" cy="2713988"/>
         </p:xfrm>
         <a:graphic>
@@ -9236,6 +9253,42 @@
           </a:p>
         </p:txBody>
       </p:sp>
+      <p:pic>
+        <p:nvPicPr>
+          <p:cNvPr id="13" name="Image 12">
+            <a:extLst>
+              <a:ext uri="{FF2B5EF4-FFF2-40B4-BE49-F238E27FC236}">
+                <a16:creationId xmlns:a16="http://schemas.microsoft.com/office/drawing/2014/main" id="{4661DE57-0521-071E-41E3-88903679B4FA}"/>
+              </a:ext>
+            </a:extLst>
+          </p:cNvPr>
+          <p:cNvPicPr>
+            <a:picLocks noChangeAspect="1"/>
+          </p:cNvPicPr>
+          <p:nvPr/>
+        </p:nvPicPr>
+        <p:blipFill>
+          <a:blip r:embed="rId2">
+            <a:extLst>
+              <a:ext uri="{28A0092B-C50C-407E-A947-70E740481C1C}">
+                <a14:useLocalDpi xmlns:a14="http://schemas.microsoft.com/office/drawing/2010/main" val="0"/>
+              </a:ext>
+            </a:extLst>
+          </a:blip>
+          <a:stretch>
+            <a:fillRect/>
+          </a:stretch>
+        </p:blipFill>
+        <p:spPr>
+          <a:xfrm>
+            <a:off x="11288700" y="103820"/>
+            <a:ext cx="812242" cy="1143636"/>
+          </a:xfrm>
+          <a:prstGeom prst="rect">
+            <a:avLst/>
+          </a:prstGeom>
+        </p:spPr>
+      </p:pic>
     </p:spTree>
   </p:cSld>
   <p:clrMapOvr>
@@ -9261,6 +9314,450 @@
           <a:chExt cx="0" cy="0"/>
         </a:xfrm>
       </p:grpSpPr>
+      <p:sp>
+        <p:nvSpPr>
+          <p:cNvPr id="62" name="object 62"/>
+          <p:cNvSpPr txBox="1"/>
+          <p:nvPr/>
+        </p:nvSpPr>
+        <p:spPr>
+          <a:xfrm>
+            <a:off x="939799" y="5396810"/>
+            <a:ext cx="5180330" cy="618490"/>
+          </a:xfrm>
+          <a:prstGeom prst="rect">
+            <a:avLst/>
+          </a:prstGeom>
+        </p:spPr>
+        <p:txBody>
+          <a:bodyPr vert="horz" wrap="square" lIns="0" tIns="13970" rIns="0" bIns="0" rtlCol="0">
+            <a:spAutoFit/>
+          </a:bodyPr>
+          <a:lstStyle/>
+          <a:p>
+            <a:pPr marL="1344930">
+              <a:lnSpc>
+                <a:spcPct val="100000"/>
+              </a:lnSpc>
+              <a:spcBef>
+                <a:spcPts val="110"/>
+              </a:spcBef>
+            </a:pPr>
+            <a:r>
+              <a:rPr sz="1100" spc="-35" dirty="0">
+                <a:solidFill>
+                  <a:srgbClr val="4A4A4A"/>
+                </a:solidFill>
+                <a:latin typeface="Arial MT"/>
+                <a:cs typeface="Arial MT"/>
+              </a:rPr>
+              <a:t>Réplique</a:t>
+            </a:r>
+            <a:r>
+              <a:rPr sz="1100" spc="-65" dirty="0">
+                <a:solidFill>
+                  <a:srgbClr val="4A4A4A"/>
+                </a:solidFill>
+                <a:latin typeface="Arial MT"/>
+                <a:cs typeface="Arial MT"/>
+              </a:rPr>
+              <a:t> </a:t>
+            </a:r>
+            <a:r>
+              <a:rPr sz="1100" spc="-35" dirty="0">
+                <a:solidFill>
+                  <a:srgbClr val="4A4A4A"/>
+                </a:solidFill>
+                <a:latin typeface="Arial MT"/>
+                <a:cs typeface="Arial MT"/>
+              </a:rPr>
+              <a:t>de</a:t>
+            </a:r>
+            <a:r>
+              <a:rPr sz="1100" spc="-60" dirty="0">
+                <a:solidFill>
+                  <a:srgbClr val="4A4A4A"/>
+                </a:solidFill>
+                <a:latin typeface="Arial MT"/>
+                <a:cs typeface="Arial MT"/>
+              </a:rPr>
+              <a:t> </a:t>
+            </a:r>
+            <a:r>
+              <a:rPr sz="1100" spc="-25" dirty="0">
+                <a:solidFill>
+                  <a:srgbClr val="4A4A4A"/>
+                </a:solidFill>
+                <a:latin typeface="Arial MT"/>
+                <a:cs typeface="Arial MT"/>
+              </a:rPr>
+              <a:t>l’historique,</a:t>
+            </a:r>
+            <a:r>
+              <a:rPr sz="1100" spc="50" dirty="0">
+                <a:solidFill>
+                  <a:srgbClr val="4A4A4A"/>
+                </a:solidFill>
+                <a:latin typeface="Arial MT"/>
+                <a:cs typeface="Arial MT"/>
+              </a:rPr>
+              <a:t> </a:t>
+            </a:r>
+            <a:r>
+              <a:rPr sz="1100" spc="-25" dirty="0">
+                <a:solidFill>
+                  <a:srgbClr val="4A4A4A"/>
+                </a:solidFill>
+                <a:latin typeface="Arial MT"/>
+                <a:cs typeface="Arial MT"/>
+              </a:rPr>
+              <a:t>consultation </a:t>
+            </a:r>
+            <a:r>
+              <a:rPr sz="1100" spc="-20" dirty="0">
+                <a:solidFill>
+                  <a:srgbClr val="4A4A4A"/>
+                </a:solidFill>
+                <a:latin typeface="Arial MT"/>
+                <a:cs typeface="Arial MT"/>
+              </a:rPr>
+              <a:t>hors</a:t>
+            </a:r>
+            <a:r>
+              <a:rPr sz="1100" spc="-55" dirty="0">
+                <a:solidFill>
+                  <a:srgbClr val="4A4A4A"/>
+                </a:solidFill>
+                <a:latin typeface="Arial MT"/>
+                <a:cs typeface="Arial MT"/>
+              </a:rPr>
+              <a:t> </a:t>
+            </a:r>
+            <a:r>
+              <a:rPr sz="1100" spc="-25" dirty="0">
+                <a:solidFill>
+                  <a:srgbClr val="4A4A4A"/>
+                </a:solidFill>
+                <a:latin typeface="Arial MT"/>
+                <a:cs typeface="Arial MT"/>
+              </a:rPr>
+              <a:t>site,</a:t>
+            </a:r>
+            <a:r>
+              <a:rPr sz="1100" spc="50" dirty="0">
+                <a:solidFill>
+                  <a:srgbClr val="4A4A4A"/>
+                </a:solidFill>
+                <a:latin typeface="Arial MT"/>
+                <a:cs typeface="Arial MT"/>
+              </a:rPr>
+              <a:t> </a:t>
+            </a:r>
+            <a:r>
+              <a:rPr sz="1100" spc="-30" dirty="0">
+                <a:solidFill>
+                  <a:srgbClr val="4A4A4A"/>
+                </a:solidFill>
+                <a:latin typeface="Arial MT"/>
+                <a:cs typeface="Arial MT"/>
+              </a:rPr>
+              <a:t>bases</a:t>
+            </a:r>
+            <a:r>
+              <a:rPr sz="1100" spc="-50" dirty="0">
+                <a:solidFill>
+                  <a:srgbClr val="4A4A4A"/>
+                </a:solidFill>
+                <a:latin typeface="Arial MT"/>
+                <a:cs typeface="Arial MT"/>
+              </a:rPr>
+              <a:t> </a:t>
+            </a:r>
+            <a:r>
+              <a:rPr sz="1100" spc="-10" dirty="0">
+                <a:solidFill>
+                  <a:srgbClr val="4A4A4A"/>
+                </a:solidFill>
+                <a:latin typeface="Arial MT"/>
+                <a:cs typeface="Arial MT"/>
+              </a:rPr>
+              <a:t>managées</a:t>
+            </a:r>
+            <a:endParaRPr sz="1100" dirty="0">
+              <a:latin typeface="Arial MT"/>
+              <a:cs typeface="Arial MT"/>
+            </a:endParaRPr>
+          </a:p>
+          <a:p>
+            <a:pPr>
+              <a:lnSpc>
+                <a:spcPct val="100000"/>
+              </a:lnSpc>
+              <a:spcBef>
+                <a:spcPts val="740"/>
+              </a:spcBef>
+            </a:pPr>
+            <a:endParaRPr sz="1050" dirty="0">
+              <a:latin typeface="Arial MT"/>
+              <a:cs typeface="Arial MT"/>
+            </a:endParaRPr>
+          </a:p>
+          <a:p>
+            <a:pPr marL="12700">
+              <a:lnSpc>
+                <a:spcPct val="100000"/>
+              </a:lnSpc>
+              <a:tabLst>
+                <a:tab pos="2863215" algn="l"/>
+              </a:tabLst>
+            </a:pPr>
+            <a:r>
+              <a:rPr sz="1150" spc="-20" dirty="0">
+                <a:solidFill>
+                  <a:srgbClr val="4A4A4A"/>
+                </a:solidFill>
+                <a:latin typeface="Arial MT"/>
+                <a:cs typeface="Arial MT"/>
+              </a:rPr>
+              <a:t>sans</a:t>
+            </a:r>
+            <a:r>
+              <a:rPr sz="1150" spc="-70" dirty="0">
+                <a:solidFill>
+                  <a:srgbClr val="4A4A4A"/>
+                </a:solidFill>
+                <a:latin typeface="Arial MT"/>
+                <a:cs typeface="Arial MT"/>
+              </a:rPr>
+              <a:t> </a:t>
+            </a:r>
+            <a:r>
+              <a:rPr sz="1150" spc="-10" dirty="0">
+                <a:solidFill>
+                  <a:srgbClr val="4A4A4A"/>
+                </a:solidFill>
+                <a:latin typeface="Arial MT"/>
+                <a:cs typeface="Arial MT"/>
+              </a:rPr>
+              <a:t>état</a:t>
+            </a:r>
+            <a:r>
+              <a:rPr lang="fr-FR" sz="1150" spc="-65" dirty="0">
+                <a:solidFill>
+                  <a:srgbClr val="4A4A4A"/>
+                </a:solidFill>
+                <a:latin typeface="Arial MT"/>
+                <a:cs typeface="Arial MT"/>
+              </a:rPr>
+              <a:t>, </a:t>
+            </a:r>
+            <a:r>
+              <a:rPr sz="1150" spc="-20" dirty="0">
+                <a:solidFill>
+                  <a:srgbClr val="4A4A4A"/>
+                </a:solidFill>
+                <a:latin typeface="Arial MT"/>
+                <a:cs typeface="Arial MT"/>
+              </a:rPr>
+              <a:t>se</a:t>
+            </a:r>
+            <a:r>
+              <a:rPr sz="1150" spc="-70" dirty="0">
+                <a:solidFill>
+                  <a:srgbClr val="4A4A4A"/>
+                </a:solidFill>
+                <a:latin typeface="Arial MT"/>
+                <a:cs typeface="Arial MT"/>
+              </a:rPr>
+              <a:t> </a:t>
+            </a:r>
+            <a:r>
+              <a:rPr sz="1150" spc="-20" dirty="0">
+                <a:solidFill>
+                  <a:srgbClr val="4A4A4A"/>
+                </a:solidFill>
+                <a:latin typeface="Arial MT"/>
+                <a:cs typeface="Arial MT"/>
+              </a:rPr>
+              <a:t>réplique</a:t>
+            </a:r>
+            <a:r>
+              <a:rPr sz="1150" spc="-75" dirty="0">
+                <a:solidFill>
+                  <a:srgbClr val="4A4A4A"/>
+                </a:solidFill>
+                <a:latin typeface="Arial MT"/>
+                <a:cs typeface="Arial MT"/>
+              </a:rPr>
+              <a:t> </a:t>
+            </a:r>
+            <a:r>
+              <a:rPr sz="1150" spc="-25" dirty="0">
+                <a:solidFill>
+                  <a:srgbClr val="4A4A4A"/>
+                </a:solidFill>
+                <a:latin typeface="Arial MT"/>
+                <a:cs typeface="Arial MT"/>
+              </a:rPr>
+              <a:t>avec</a:t>
+            </a:r>
+            <a:r>
+              <a:rPr sz="1150" spc="-75" dirty="0">
+                <a:solidFill>
+                  <a:srgbClr val="4A4A4A"/>
+                </a:solidFill>
+                <a:latin typeface="Arial MT"/>
+                <a:cs typeface="Arial MT"/>
+              </a:rPr>
+              <a:t> </a:t>
+            </a:r>
+            <a:r>
+              <a:rPr sz="1575" spc="-127" baseline="2645" dirty="0">
+                <a:solidFill>
+                  <a:srgbClr val="4A4A4A"/>
+                </a:solidFill>
+                <a:latin typeface="Lucida Console"/>
+                <a:cs typeface="Lucida Console"/>
+              </a:rPr>
+              <a:t>-</a:t>
+            </a:r>
+            <a:r>
+              <a:rPr sz="1575" spc="-262" baseline="2645" dirty="0">
+                <a:solidFill>
+                  <a:srgbClr val="4A4A4A"/>
+                </a:solidFill>
+                <a:latin typeface="Lucida Console"/>
+                <a:cs typeface="Lucida Console"/>
+              </a:rPr>
+              <a:t>-</a:t>
+            </a:r>
+            <a:r>
+              <a:rPr sz="1575" spc="-794" baseline="2645" dirty="0">
+                <a:solidFill>
+                  <a:srgbClr val="4A4A4A"/>
+                </a:solidFill>
+                <a:latin typeface="Lucida Console"/>
+                <a:cs typeface="Lucida Console"/>
+              </a:rPr>
+              <a:t> </a:t>
+            </a:r>
+            <a:r>
+              <a:rPr sz="1575" spc="-30" baseline="2645" dirty="0">
+                <a:solidFill>
+                  <a:srgbClr val="4A4A4A"/>
+                </a:solidFill>
+                <a:latin typeface="Lucida Console"/>
+                <a:cs typeface="Lucida Console"/>
+              </a:rPr>
+              <a:t>scale</a:t>
+            </a:r>
+            <a:r>
+              <a:rPr sz="1575" baseline="2645" dirty="0">
+                <a:solidFill>
+                  <a:srgbClr val="4A4A4A"/>
+                </a:solidFill>
+                <a:latin typeface="Lucida Console"/>
+                <a:cs typeface="Lucida Console"/>
+              </a:rPr>
+              <a:t>	</a:t>
+            </a:r>
+            <a:r>
+              <a:rPr sz="1150" spc="-25" dirty="0">
+                <a:solidFill>
+                  <a:srgbClr val="4A4A4A"/>
+                </a:solidFill>
+                <a:latin typeface="Arial MT"/>
+                <a:cs typeface="Arial MT"/>
+              </a:rPr>
+              <a:t>avec</a:t>
+            </a:r>
+            <a:r>
+              <a:rPr sz="1150" spc="-85" dirty="0">
+                <a:solidFill>
+                  <a:srgbClr val="4A4A4A"/>
+                </a:solidFill>
+                <a:latin typeface="Arial MT"/>
+                <a:cs typeface="Arial MT"/>
+              </a:rPr>
+              <a:t> </a:t>
+            </a:r>
+            <a:r>
+              <a:rPr sz="1150" spc="-10" dirty="0">
+                <a:solidFill>
+                  <a:srgbClr val="4A4A4A"/>
+                </a:solidFill>
+                <a:latin typeface="Arial MT"/>
+                <a:cs typeface="Arial MT"/>
+              </a:rPr>
+              <a:t>état</a:t>
+            </a:r>
+            <a:r>
+              <a:rPr sz="1150" spc="-75" dirty="0">
+                <a:solidFill>
+                  <a:srgbClr val="4A4A4A"/>
+                </a:solidFill>
+                <a:latin typeface="Arial MT"/>
+                <a:cs typeface="Arial MT"/>
+              </a:rPr>
+              <a:t> </a:t>
+            </a:r>
+            <a:r>
+              <a:rPr sz="1150" spc="-130" dirty="0">
+                <a:solidFill>
+                  <a:srgbClr val="4A4A4A"/>
+                </a:solidFill>
+                <a:latin typeface="Arial MT"/>
+                <a:cs typeface="Arial MT"/>
+              </a:rPr>
+              <a:t>·</a:t>
+            </a:r>
+            <a:r>
+              <a:rPr sz="1150" spc="50" dirty="0">
+                <a:solidFill>
+                  <a:srgbClr val="4A4A4A"/>
+                </a:solidFill>
+                <a:latin typeface="Arial MT"/>
+                <a:cs typeface="Arial MT"/>
+              </a:rPr>
+              <a:t> </a:t>
+            </a:r>
+            <a:r>
+              <a:rPr sz="1150" spc="-10" dirty="0">
+                <a:solidFill>
+                  <a:srgbClr val="4A4A4A"/>
+                </a:solidFill>
+                <a:latin typeface="Arial MT"/>
+                <a:cs typeface="Arial MT"/>
+              </a:rPr>
+              <a:t>volume</a:t>
+            </a:r>
+            <a:r>
+              <a:rPr sz="1150" spc="-80" dirty="0">
+                <a:solidFill>
+                  <a:srgbClr val="4A4A4A"/>
+                </a:solidFill>
+                <a:latin typeface="Arial MT"/>
+                <a:cs typeface="Arial MT"/>
+              </a:rPr>
+              <a:t> </a:t>
+            </a:r>
+            <a:r>
+              <a:rPr sz="1150" spc="-10" dirty="0">
+                <a:solidFill>
+                  <a:srgbClr val="4A4A4A"/>
+                </a:solidFill>
+                <a:latin typeface="Arial MT"/>
+                <a:cs typeface="Arial MT"/>
+              </a:rPr>
+              <a:t>persistant</a:t>
+            </a:r>
+            <a:endParaRPr sz="1150" dirty="0">
+              <a:latin typeface="Arial MT"/>
+              <a:cs typeface="Arial MT"/>
+            </a:endParaRPr>
+          </a:p>
+        </p:txBody>
+      </p:sp>
       <p:sp>
         <p:nvSpPr>
           <p:cNvPr id="2" name="object 2" descr="$PPTXTitle"/>
@@ -13956,7 +14453,7 @@
         <p:spPr>
           <a:xfrm>
             <a:off x="2272307" y="1749115"/>
-            <a:ext cx="3768090" cy="183515"/>
+            <a:ext cx="3768090" cy="171201"/>
           </a:xfrm>
           <a:prstGeom prst="rect">
             <a:avLst/>
@@ -14015,16 +14512,6 @@
                 <a:cs typeface="Arial"/>
               </a:rPr>
               <a:t> </a:t>
-            </a:r>
-            <a:r>
-              <a:rPr sz="1000" b="1" dirty="0">
-                <a:solidFill>
-                  <a:srgbClr val="6A6A6A"/>
-                </a:solidFill>
-                <a:latin typeface="Arial"/>
-                <a:cs typeface="Arial"/>
-              </a:rPr>
-              <a:t>·</a:t>
             </a:r>
             <a:r>
               <a:rPr sz="1000" b="1" spc="150" dirty="0">
@@ -14229,56 +14716,6 @@
               <a:latin typeface="Arial"/>
               <a:cs typeface="Arial"/>
             </a:endParaRPr>
-          </a:p>
-        </p:txBody>
-      </p:sp>
-      <p:sp>
-        <p:nvSpPr>
-          <p:cNvPr id="63" name="object 63"/>
-          <p:cNvSpPr/>
-          <p:nvPr/>
-        </p:nvSpPr>
-        <p:spPr>
-          <a:xfrm>
-            <a:off x="7143749" y="2009774"/>
-            <a:ext cx="4438650" cy="9525"/>
-          </a:xfrm>
-          <a:custGeom>
-            <a:avLst/>
-            <a:gdLst/>
-            <a:ahLst/>
-            <a:cxnLst/>
-            <a:rect l="l" t="t" r="r" b="b"/>
-            <a:pathLst>
-              <a:path w="4438650" h="9525">
-                <a:moveTo>
-                  <a:pt x="4438649" y="9524"/>
-                </a:moveTo>
-                <a:lnTo>
-                  <a:pt x="0" y="9524"/>
-                </a:lnTo>
-                <a:lnTo>
-                  <a:pt x="0" y="0"/>
-                </a:lnTo>
-                <a:lnTo>
-                  <a:pt x="4438649" y="0"/>
-                </a:lnTo>
-                <a:lnTo>
-                  <a:pt x="4438649" y="9524"/>
-                </a:lnTo>
-                <a:close/>
-              </a:path>
-            </a:pathLst>
-          </a:custGeom>
-          <a:solidFill>
-            <a:srgbClr val="1F36C7"/>
-          </a:solidFill>
-        </p:spPr>
-        <p:txBody>
-          <a:bodyPr wrap="square" lIns="0" tIns="0" rIns="0" bIns="0" rtlCol="0"/>
-          <a:lstStyle/>
-          <a:p>
-            <a:endParaRPr/>
           </a:p>
         </p:txBody>
       </p:sp>
@@ -16834,7 +17271,7 @@
         <p:spPr>
           <a:xfrm>
             <a:off x="7131049" y="2175793"/>
-            <a:ext cx="4348480" cy="739775"/>
+            <a:ext cx="4348480" cy="716606"/>
           </a:xfrm>
           <a:prstGeom prst="rect">
             <a:avLst/>
@@ -16895,14 +17332,14 @@
               <a:t> </a:t>
             </a:r>
             <a:r>
-              <a:rPr sz="1400" b="1" spc="80" dirty="0">
+              <a:rPr lang="fr-FR" sz="1400" b="1" spc="80" dirty="0">
                 <a:solidFill>
                   <a:srgbClr val="111111"/>
                 </a:solidFill>
                 <a:latin typeface="Arial"/>
                 <a:cs typeface="Arial"/>
               </a:rPr>
-              <a:t>—</a:t>
+              <a:t>:</a:t>
             </a:r>
             <a:r>
               <a:rPr sz="1400" b="1" spc="-250" dirty="0">
@@ -16962,7 +17399,7 @@
                 <a:latin typeface="Arial"/>
                 <a:cs typeface="Arial"/>
               </a:rPr>
-              <a:t>IaaS.</a:t>
+              <a:t>IaaS</a:t>
             </a:r>
             <a:r>
               <a:rPr sz="1400" b="1" dirty="0">
@@ -17529,6 +17966,7 @@
           <a:bodyPr wrap="square" lIns="0" tIns="0" rIns="0" bIns="0" rtlCol="0"/>
           <a:lstStyle/>
           <a:p>
+            <a:pPr algn="l" rtl="0"/>
             <a:endParaRPr/>
           </a:p>
         </p:txBody>
@@ -17603,24 +18041,14 @@
               <a:t> </a:t>
             </a:r>
             <a:r>
-              <a:rPr sz="1400" b="1" spc="80" dirty="0">
+              <a:rPr lang="fr-FR" sz="1400" b="1" spc="80" dirty="0">
                 <a:solidFill>
                   <a:srgbClr val="111111"/>
                 </a:solidFill>
                 <a:latin typeface="Arial"/>
                 <a:cs typeface="Arial"/>
               </a:rPr>
-              <a:t>—</a:t>
-            </a:r>
-            <a:r>
-              <a:rPr sz="1400" b="1" spc="-240" dirty="0">
-                <a:solidFill>
-                  <a:srgbClr val="111111"/>
-                </a:solidFill>
-                <a:latin typeface="Arial"/>
-                <a:cs typeface="Arial"/>
-              </a:rPr>
-              <a:t> </a:t>
+              <a:t>: </a:t>
             </a:r>
             <a:r>
               <a:rPr sz="1400" b="1" spc="-40" dirty="0">
@@ -18051,6 +18479,7 @@
           <a:bodyPr wrap="square" lIns="0" tIns="0" rIns="0" bIns="0" rtlCol="0"/>
           <a:lstStyle/>
           <a:p>
+            <a:pPr algn="l" rtl="0"/>
             <a:endParaRPr/>
           </a:p>
         </p:txBody>
@@ -20986,7 +21415,7 @@
         <p:spPr>
           <a:xfrm>
             <a:off x="2272307" y="5181092"/>
-            <a:ext cx="2846705" cy="183515"/>
+            <a:ext cx="2846705" cy="171201"/>
           </a:xfrm>
           <a:prstGeom prst="rect">
             <a:avLst/>
@@ -21047,54 +21476,34 @@
               <a:t> </a:t>
             </a:r>
             <a:r>
-              <a:rPr sz="1000" b="1" dirty="0">
+              <a:rPr sz="1000" b="1" spc="105" dirty="0">
                 <a:solidFill>
                   <a:srgbClr val="6A6A6A"/>
                 </a:solidFill>
                 <a:latin typeface="Arial"/>
                 <a:cs typeface="Arial"/>
               </a:rPr>
-              <a:t>·</a:t>
-            </a:r>
-            <a:r>
-              <a:rPr sz="1000" b="1" spc="105" dirty="0">
+              <a:t> </a:t>
+            </a:r>
+            <a:r>
+              <a:rPr sz="1000" b="1" dirty="0">
                 <a:solidFill>
                   <a:srgbClr val="6A6A6A"/>
                 </a:solidFill>
                 <a:latin typeface="Arial"/>
                 <a:cs typeface="Arial"/>
               </a:rPr>
-              <a:t> </a:t>
-            </a:r>
-            <a:r>
-              <a:rPr sz="1000" b="1" dirty="0">
+              <a:t>PaaS</a:t>
+            </a:r>
+            <a:r>
+              <a:rPr sz="1000" b="1" spc="5" dirty="0">
                 <a:solidFill>
                   <a:srgbClr val="6A6A6A"/>
                 </a:solidFill>
                 <a:latin typeface="Arial"/>
                 <a:cs typeface="Arial"/>
               </a:rPr>
-              <a:t>PaaS</a:t>
-            </a:r>
-            <a:r>
-              <a:rPr sz="1000" b="1" spc="5" dirty="0">
-                <a:solidFill>
-                  <a:srgbClr val="6A6A6A"/>
-                </a:solidFill>
-                <a:latin typeface="Arial"/>
-                <a:cs typeface="Arial"/>
-              </a:rPr>
-              <a:t> </a:t>
-            </a:r>
-            <a:r>
-              <a:rPr sz="1000" b="1" dirty="0">
-                <a:solidFill>
-                  <a:srgbClr val="6A6A6A"/>
-                </a:solidFill>
-                <a:latin typeface="Arial"/>
-                <a:cs typeface="Arial"/>
-              </a:rPr>
-              <a:t>·</a:t>
+              <a:t> </a:t>
             </a:r>
             <a:r>
               <a:rPr sz="1000" b="1" spc="105" dirty="0">
@@ -21193,7 +21602,7 @@
         </p:nvSpPr>
         <p:spPr>
           <a:xfrm>
-            <a:off x="3467100" y="5891212"/>
+            <a:off x="3467100" y="5867400"/>
             <a:ext cx="190500" cy="104775"/>
           </a:xfrm>
           <a:custGeom>
@@ -21231,471 +21640,8 @@
           <a:bodyPr wrap="square" lIns="0" tIns="0" rIns="0" bIns="0" rtlCol="0"/>
           <a:lstStyle/>
           <a:p>
+            <a:pPr algn="l" rtl="0"/>
             <a:endParaRPr/>
-          </a:p>
-        </p:txBody>
-      </p:sp>
-      <p:sp>
-        <p:nvSpPr>
-          <p:cNvPr id="62" name="object 62"/>
-          <p:cNvSpPr txBox="1"/>
-          <p:nvPr/>
-        </p:nvSpPr>
-        <p:spPr>
-          <a:xfrm>
-            <a:off x="939799" y="5396810"/>
-            <a:ext cx="5180330" cy="618490"/>
-          </a:xfrm>
-          <a:prstGeom prst="rect">
-            <a:avLst/>
-          </a:prstGeom>
-        </p:spPr>
-        <p:txBody>
-          <a:bodyPr vert="horz" wrap="square" lIns="0" tIns="13970" rIns="0" bIns="0" rtlCol="0">
-            <a:spAutoFit/>
-          </a:bodyPr>
-          <a:lstStyle/>
-          <a:p>
-            <a:pPr marL="1344930">
-              <a:lnSpc>
-                <a:spcPct val="100000"/>
-              </a:lnSpc>
-              <a:spcBef>
-                <a:spcPts val="110"/>
-              </a:spcBef>
-            </a:pPr>
-            <a:r>
-              <a:rPr sz="1100" spc="-35" dirty="0">
-                <a:solidFill>
-                  <a:srgbClr val="4A4A4A"/>
-                </a:solidFill>
-                <a:latin typeface="Arial MT"/>
-                <a:cs typeface="Arial MT"/>
-              </a:rPr>
-              <a:t>Réplique</a:t>
-            </a:r>
-            <a:r>
-              <a:rPr sz="1100" spc="-65" dirty="0">
-                <a:solidFill>
-                  <a:srgbClr val="4A4A4A"/>
-                </a:solidFill>
-                <a:latin typeface="Arial MT"/>
-                <a:cs typeface="Arial MT"/>
-              </a:rPr>
-              <a:t> </a:t>
-            </a:r>
-            <a:r>
-              <a:rPr sz="1100" spc="-35" dirty="0">
-                <a:solidFill>
-                  <a:srgbClr val="4A4A4A"/>
-                </a:solidFill>
-                <a:latin typeface="Arial MT"/>
-                <a:cs typeface="Arial MT"/>
-              </a:rPr>
-              <a:t>de</a:t>
-            </a:r>
-            <a:r>
-              <a:rPr sz="1100" spc="-60" dirty="0">
-                <a:solidFill>
-                  <a:srgbClr val="4A4A4A"/>
-                </a:solidFill>
-                <a:latin typeface="Arial MT"/>
-                <a:cs typeface="Arial MT"/>
-              </a:rPr>
-              <a:t> </a:t>
-            </a:r>
-            <a:r>
-              <a:rPr sz="1100" spc="-25" dirty="0">
-                <a:solidFill>
-                  <a:srgbClr val="4A4A4A"/>
-                </a:solidFill>
-                <a:latin typeface="Arial MT"/>
-                <a:cs typeface="Arial MT"/>
-              </a:rPr>
-              <a:t>l’historique,</a:t>
-            </a:r>
-            <a:r>
-              <a:rPr sz="1100" spc="50" dirty="0">
-                <a:solidFill>
-                  <a:srgbClr val="4A4A4A"/>
-                </a:solidFill>
-                <a:latin typeface="Arial MT"/>
-                <a:cs typeface="Arial MT"/>
-              </a:rPr>
-              <a:t> </a:t>
-            </a:r>
-            <a:r>
-              <a:rPr sz="1100" spc="-25" dirty="0">
-                <a:solidFill>
-                  <a:srgbClr val="4A4A4A"/>
-                </a:solidFill>
-                <a:latin typeface="Arial MT"/>
-                <a:cs typeface="Arial MT"/>
-              </a:rPr>
-              <a:t>consultation </a:t>
-            </a:r>
-            <a:r>
-              <a:rPr sz="1100" spc="-20" dirty="0">
-                <a:solidFill>
-                  <a:srgbClr val="4A4A4A"/>
-                </a:solidFill>
-                <a:latin typeface="Arial MT"/>
-                <a:cs typeface="Arial MT"/>
-              </a:rPr>
-              <a:t>hors</a:t>
-            </a:r>
-            <a:r>
-              <a:rPr sz="1100" spc="-55" dirty="0">
-                <a:solidFill>
-                  <a:srgbClr val="4A4A4A"/>
-                </a:solidFill>
-                <a:latin typeface="Arial MT"/>
-                <a:cs typeface="Arial MT"/>
-              </a:rPr>
-              <a:t> </a:t>
-            </a:r>
-            <a:r>
-              <a:rPr sz="1100" spc="-25" dirty="0">
-                <a:solidFill>
-                  <a:srgbClr val="4A4A4A"/>
-                </a:solidFill>
-                <a:latin typeface="Arial MT"/>
-                <a:cs typeface="Arial MT"/>
-              </a:rPr>
-              <a:t>site,</a:t>
-            </a:r>
-            <a:r>
-              <a:rPr sz="1100" spc="50" dirty="0">
-                <a:solidFill>
-                  <a:srgbClr val="4A4A4A"/>
-                </a:solidFill>
-                <a:latin typeface="Arial MT"/>
-                <a:cs typeface="Arial MT"/>
-              </a:rPr>
-              <a:t> </a:t>
-            </a:r>
-            <a:r>
-              <a:rPr sz="1100" spc="-30" dirty="0">
-                <a:solidFill>
-                  <a:srgbClr val="4A4A4A"/>
-                </a:solidFill>
-                <a:latin typeface="Arial MT"/>
-                <a:cs typeface="Arial MT"/>
-              </a:rPr>
-              <a:t>bases</a:t>
-            </a:r>
-            <a:r>
-              <a:rPr sz="1100" spc="-50" dirty="0">
-                <a:solidFill>
-                  <a:srgbClr val="4A4A4A"/>
-                </a:solidFill>
-                <a:latin typeface="Arial MT"/>
-                <a:cs typeface="Arial MT"/>
-              </a:rPr>
-              <a:t> </a:t>
-            </a:r>
-            <a:r>
-              <a:rPr sz="1100" spc="-10" dirty="0">
-                <a:solidFill>
-                  <a:srgbClr val="4A4A4A"/>
-                </a:solidFill>
-                <a:latin typeface="Arial MT"/>
-                <a:cs typeface="Arial MT"/>
-              </a:rPr>
-              <a:t>managées</a:t>
-            </a:r>
-            <a:endParaRPr sz="1100" dirty="0">
-              <a:latin typeface="Arial MT"/>
-              <a:cs typeface="Arial MT"/>
-            </a:endParaRPr>
-          </a:p>
-          <a:p>
-            <a:pPr>
-              <a:lnSpc>
-                <a:spcPct val="100000"/>
-              </a:lnSpc>
-              <a:spcBef>
-                <a:spcPts val="740"/>
-              </a:spcBef>
-            </a:pPr>
-            <a:endParaRPr sz="1050" dirty="0">
-              <a:latin typeface="Arial MT"/>
-              <a:cs typeface="Arial MT"/>
-            </a:endParaRPr>
-          </a:p>
-          <a:p>
-            <a:pPr marL="12700">
-              <a:lnSpc>
-                <a:spcPct val="100000"/>
-              </a:lnSpc>
-              <a:tabLst>
-                <a:tab pos="2863215" algn="l"/>
-              </a:tabLst>
-            </a:pPr>
-            <a:r>
-              <a:rPr sz="1150" spc="-20" dirty="0">
-                <a:solidFill>
-                  <a:srgbClr val="4A4A4A"/>
-                </a:solidFill>
-                <a:latin typeface="Arial MT"/>
-                <a:cs typeface="Arial MT"/>
-              </a:rPr>
-              <a:t>sans</a:t>
-            </a:r>
-            <a:r>
-              <a:rPr sz="1150" spc="-70" dirty="0">
-                <a:solidFill>
-                  <a:srgbClr val="4A4A4A"/>
-                </a:solidFill>
-                <a:latin typeface="Arial MT"/>
-                <a:cs typeface="Arial MT"/>
-              </a:rPr>
-              <a:t> </a:t>
-            </a:r>
-            <a:r>
-              <a:rPr sz="1150" spc="-10" dirty="0">
-                <a:solidFill>
-                  <a:srgbClr val="4A4A4A"/>
-                </a:solidFill>
-                <a:latin typeface="Arial MT"/>
-                <a:cs typeface="Arial MT"/>
-              </a:rPr>
-              <a:t>état</a:t>
-            </a:r>
-            <a:r>
-              <a:rPr sz="1150" spc="-65" dirty="0">
-                <a:solidFill>
-                  <a:srgbClr val="4A4A4A"/>
-                </a:solidFill>
-                <a:latin typeface="Arial MT"/>
-                <a:cs typeface="Arial MT"/>
-              </a:rPr>
-              <a:t> </a:t>
-            </a:r>
-            <a:r>
-              <a:rPr sz="1150" spc="-130" dirty="0">
-                <a:solidFill>
-                  <a:srgbClr val="4A4A4A"/>
-                </a:solidFill>
-                <a:latin typeface="Arial MT"/>
-                <a:cs typeface="Arial MT"/>
-              </a:rPr>
-              <a:t>·</a:t>
-            </a:r>
-            <a:r>
-              <a:rPr sz="1150" spc="70" dirty="0">
-                <a:solidFill>
-                  <a:srgbClr val="4A4A4A"/>
-                </a:solidFill>
-                <a:latin typeface="Arial MT"/>
-                <a:cs typeface="Arial MT"/>
-              </a:rPr>
-              <a:t> </a:t>
-            </a:r>
-            <a:r>
-              <a:rPr sz="1150" spc="-20" dirty="0">
-                <a:solidFill>
-                  <a:srgbClr val="4A4A4A"/>
-                </a:solidFill>
-                <a:latin typeface="Arial MT"/>
-                <a:cs typeface="Arial MT"/>
-              </a:rPr>
-              <a:t>se</a:t>
-            </a:r>
-            <a:r>
-              <a:rPr sz="1150" spc="-70" dirty="0">
-                <a:solidFill>
-                  <a:srgbClr val="4A4A4A"/>
-                </a:solidFill>
-                <a:latin typeface="Arial MT"/>
-                <a:cs typeface="Arial MT"/>
-              </a:rPr>
-              <a:t> </a:t>
-            </a:r>
-            <a:r>
-              <a:rPr sz="1150" spc="-20" dirty="0">
-                <a:solidFill>
-                  <a:srgbClr val="4A4A4A"/>
-                </a:solidFill>
-                <a:latin typeface="Arial MT"/>
-                <a:cs typeface="Arial MT"/>
-              </a:rPr>
-              <a:t>réplique</a:t>
-            </a:r>
-            <a:r>
-              <a:rPr sz="1150" spc="-75" dirty="0">
-                <a:solidFill>
-                  <a:srgbClr val="4A4A4A"/>
-                </a:solidFill>
-                <a:latin typeface="Arial MT"/>
-                <a:cs typeface="Arial MT"/>
-              </a:rPr>
-              <a:t> </a:t>
-            </a:r>
-            <a:r>
-              <a:rPr sz="1150" spc="-25" dirty="0">
-                <a:solidFill>
-                  <a:srgbClr val="4A4A4A"/>
-                </a:solidFill>
-                <a:latin typeface="Arial MT"/>
-                <a:cs typeface="Arial MT"/>
-              </a:rPr>
-              <a:t>avec</a:t>
-            </a:r>
-            <a:r>
-              <a:rPr sz="1150" spc="-75" dirty="0">
-                <a:solidFill>
-                  <a:srgbClr val="4A4A4A"/>
-                </a:solidFill>
-                <a:latin typeface="Arial MT"/>
-                <a:cs typeface="Arial MT"/>
-              </a:rPr>
-              <a:t> </a:t>
-            </a:r>
-            <a:r>
-              <a:rPr sz="1575" spc="-127" baseline="2645" dirty="0">
-                <a:solidFill>
-                  <a:srgbClr val="4A4A4A"/>
-                </a:solidFill>
-                <a:latin typeface="Lucida Console"/>
-                <a:cs typeface="Lucida Console"/>
-              </a:rPr>
-              <a:t>-</a:t>
-            </a:r>
-            <a:r>
-              <a:rPr sz="1575" spc="-262" baseline="2645" dirty="0">
-                <a:solidFill>
-                  <a:srgbClr val="4A4A4A"/>
-                </a:solidFill>
-                <a:latin typeface="Lucida Console"/>
-                <a:cs typeface="Lucida Console"/>
-              </a:rPr>
-              <a:t>-</a:t>
-            </a:r>
-            <a:r>
-              <a:rPr sz="1575" spc="-794" baseline="2645" dirty="0">
-                <a:solidFill>
-                  <a:srgbClr val="4A4A4A"/>
-                </a:solidFill>
-                <a:latin typeface="Lucida Console"/>
-                <a:cs typeface="Lucida Console"/>
-              </a:rPr>
-              <a:t> </a:t>
-            </a:r>
-            <a:r>
-              <a:rPr sz="1575" spc="-30" baseline="2645" dirty="0">
-                <a:solidFill>
-                  <a:srgbClr val="4A4A4A"/>
-                </a:solidFill>
-                <a:latin typeface="Lucida Console"/>
-                <a:cs typeface="Lucida Console"/>
-              </a:rPr>
-              <a:t>scale</a:t>
-            </a:r>
-            <a:r>
-              <a:rPr sz="1575" baseline="2645" dirty="0">
-                <a:solidFill>
-                  <a:srgbClr val="4A4A4A"/>
-                </a:solidFill>
-                <a:latin typeface="Lucida Console"/>
-                <a:cs typeface="Lucida Console"/>
-              </a:rPr>
-              <a:t>	</a:t>
-            </a:r>
-            <a:r>
-              <a:rPr sz="1150" spc="-25" dirty="0">
-                <a:solidFill>
-                  <a:srgbClr val="4A4A4A"/>
-                </a:solidFill>
-                <a:latin typeface="Arial MT"/>
-                <a:cs typeface="Arial MT"/>
-              </a:rPr>
-              <a:t>avec</a:t>
-            </a:r>
-            <a:r>
-              <a:rPr sz="1150" spc="-85" dirty="0">
-                <a:solidFill>
-                  <a:srgbClr val="4A4A4A"/>
-                </a:solidFill>
-                <a:latin typeface="Arial MT"/>
-                <a:cs typeface="Arial MT"/>
-              </a:rPr>
-              <a:t> </a:t>
-            </a:r>
-            <a:r>
-              <a:rPr sz="1150" spc="-10" dirty="0">
-                <a:solidFill>
-                  <a:srgbClr val="4A4A4A"/>
-                </a:solidFill>
-                <a:latin typeface="Arial MT"/>
-                <a:cs typeface="Arial MT"/>
-              </a:rPr>
-              <a:t>état</a:t>
-            </a:r>
-            <a:r>
-              <a:rPr sz="1150" spc="-75" dirty="0">
-                <a:solidFill>
-                  <a:srgbClr val="4A4A4A"/>
-                </a:solidFill>
-                <a:latin typeface="Arial MT"/>
-                <a:cs typeface="Arial MT"/>
-              </a:rPr>
-              <a:t> </a:t>
-            </a:r>
-            <a:r>
-              <a:rPr sz="1150" spc="-130" dirty="0">
-                <a:solidFill>
-                  <a:srgbClr val="4A4A4A"/>
-                </a:solidFill>
-                <a:latin typeface="Arial MT"/>
-                <a:cs typeface="Arial MT"/>
-              </a:rPr>
-              <a:t>·</a:t>
-            </a:r>
-            <a:r>
-              <a:rPr sz="1150" spc="50" dirty="0">
-                <a:solidFill>
-                  <a:srgbClr val="4A4A4A"/>
-                </a:solidFill>
-                <a:latin typeface="Arial MT"/>
-                <a:cs typeface="Arial MT"/>
-              </a:rPr>
-              <a:t> </a:t>
-            </a:r>
-            <a:r>
-              <a:rPr sz="1150" spc="-10" dirty="0">
-                <a:solidFill>
-                  <a:srgbClr val="4A4A4A"/>
-                </a:solidFill>
-                <a:latin typeface="Arial MT"/>
-                <a:cs typeface="Arial MT"/>
-              </a:rPr>
-              <a:t>volume</a:t>
-            </a:r>
-            <a:r>
-              <a:rPr sz="1150" spc="-80" dirty="0">
-                <a:solidFill>
-                  <a:srgbClr val="4A4A4A"/>
-                </a:solidFill>
-                <a:latin typeface="Arial MT"/>
-                <a:cs typeface="Arial MT"/>
-              </a:rPr>
-              <a:t> </a:t>
-            </a:r>
-            <a:r>
-              <a:rPr sz="1150" spc="-10" dirty="0">
-                <a:solidFill>
-                  <a:srgbClr val="4A4A4A"/>
-                </a:solidFill>
-                <a:latin typeface="Arial MT"/>
-                <a:cs typeface="Arial MT"/>
-              </a:rPr>
-              <a:t>persistant</a:t>
-            </a:r>
-            <a:endParaRPr sz="1150" dirty="0">
-              <a:latin typeface="Arial MT"/>
-              <a:cs typeface="Arial MT"/>
-            </a:endParaRPr>
           </a:p>
         </p:txBody>
       </p:sp>
@@ -22153,6 +22099,7 @@
           <a:bodyPr wrap="square" lIns="0" tIns="0" rIns="0" bIns="0" rtlCol="0"/>
           <a:lstStyle/>
           <a:p>
+            <a:pPr algn="l" rtl="0"/>
             <a:endParaRPr/>
           </a:p>
         </p:txBody>
@@ -22236,6 +22183,99 @@
               <a:rPr spc="-50" dirty="0"/>
               <a:t>4</a:t>
             </a:r>
+          </a:p>
+        </p:txBody>
+      </p:sp>
+      <p:pic>
+        <p:nvPicPr>
+          <p:cNvPr id="76" name="Image 75">
+            <a:extLst>
+              <a:ext uri="{FF2B5EF4-FFF2-40B4-BE49-F238E27FC236}">
+                <a16:creationId xmlns:a16="http://schemas.microsoft.com/office/drawing/2014/main" id="{537F3DA2-E42B-30EE-55E6-364516CA872F}"/>
+              </a:ext>
+            </a:extLst>
+          </p:cNvPr>
+          <p:cNvPicPr>
+            <a:picLocks noChangeAspect="1"/>
+          </p:cNvPicPr>
+          <p:nvPr/>
+        </p:nvPicPr>
+        <p:blipFill>
+          <a:blip r:embed="rId3">
+            <a:extLst>
+              <a:ext uri="{28A0092B-C50C-407E-A947-70E740481C1C}">
+                <a14:useLocalDpi xmlns:a14="http://schemas.microsoft.com/office/drawing/2010/main" val="0"/>
+              </a:ext>
+            </a:extLst>
+          </a:blip>
+          <a:stretch>
+            <a:fillRect/>
+          </a:stretch>
+        </p:blipFill>
+        <p:spPr>
+          <a:xfrm>
+            <a:off x="11288700" y="103820"/>
+            <a:ext cx="812242" cy="1143636"/>
+          </a:xfrm>
+          <a:prstGeom prst="rect">
+            <a:avLst/>
+          </a:prstGeom>
+        </p:spPr>
+      </p:pic>
+      <p:sp>
+        <p:nvSpPr>
+          <p:cNvPr id="77" name="object 65">
+            <a:extLst>
+              <a:ext uri="{FF2B5EF4-FFF2-40B4-BE49-F238E27FC236}">
+                <a16:creationId xmlns:a16="http://schemas.microsoft.com/office/drawing/2014/main" id="{9005B962-F387-72A9-7E48-40E6B92222AF}"/>
+              </a:ext>
+            </a:extLst>
+          </p:cNvPr>
+          <p:cNvSpPr/>
+          <p:nvPr/>
+        </p:nvSpPr>
+        <p:spPr>
+          <a:xfrm>
+            <a:off x="7143749" y="2033000"/>
+            <a:ext cx="4438650" cy="9525"/>
+          </a:xfrm>
+          <a:custGeom>
+            <a:avLst/>
+            <a:gdLst/>
+            <a:ahLst/>
+            <a:cxnLst/>
+            <a:rect l="l" t="t" r="r" b="b"/>
+            <a:pathLst>
+              <a:path w="4438650" h="9525">
+                <a:moveTo>
+                  <a:pt x="4438649" y="9524"/>
+                </a:moveTo>
+                <a:lnTo>
+                  <a:pt x="0" y="9524"/>
+                </a:lnTo>
+                <a:lnTo>
+                  <a:pt x="0" y="0"/>
+                </a:lnTo>
+                <a:lnTo>
+                  <a:pt x="4438649" y="0"/>
+                </a:lnTo>
+                <a:lnTo>
+                  <a:pt x="4438649" y="9524"/>
+                </a:lnTo>
+                <a:close/>
+              </a:path>
+            </a:pathLst>
+          </a:custGeom>
+          <a:solidFill>
+            <a:srgbClr val="111111"/>
+          </a:solidFill>
+        </p:spPr>
+        <p:txBody>
+          <a:bodyPr wrap="square" lIns="0" tIns="0" rIns="0" bIns="0" rtlCol="0"/>
+          <a:lstStyle/>
+          <a:p>
+            <a:pPr algn="l" rtl="0"/>
+            <a:endParaRPr/>
           </a:p>
         </p:txBody>
       </p:sp>
@@ -26112,6 +26152,42 @@
           </a:p>
         </p:txBody>
       </p:sp>
+      <p:pic>
+        <p:nvPicPr>
+          <p:cNvPr id="8" name="Image 7">
+            <a:extLst>
+              <a:ext uri="{FF2B5EF4-FFF2-40B4-BE49-F238E27FC236}">
+                <a16:creationId xmlns:a16="http://schemas.microsoft.com/office/drawing/2014/main" id="{C471B968-4290-F30B-DE31-3DFAAEC48909}"/>
+              </a:ext>
+            </a:extLst>
+          </p:cNvPr>
+          <p:cNvPicPr>
+            <a:picLocks noChangeAspect="1"/>
+          </p:cNvPicPr>
+          <p:nvPr/>
+        </p:nvPicPr>
+        <p:blipFill>
+          <a:blip r:embed="rId2">
+            <a:extLst>
+              <a:ext uri="{28A0092B-C50C-407E-A947-70E740481C1C}">
+                <a14:useLocalDpi xmlns:a14="http://schemas.microsoft.com/office/drawing/2010/main" val="0"/>
+              </a:ext>
+            </a:extLst>
+          </a:blip>
+          <a:stretch>
+            <a:fillRect/>
+          </a:stretch>
+        </p:blipFill>
+        <p:spPr>
+          <a:xfrm>
+            <a:off x="11288700" y="103820"/>
+            <a:ext cx="812242" cy="1143636"/>
+          </a:xfrm>
+          <a:prstGeom prst="rect">
+            <a:avLst/>
+          </a:prstGeom>
+        </p:spPr>
+      </p:pic>
     </p:spTree>
   </p:cSld>
   <p:clrMapOvr>

</xml_diff>

<commit_message>
fix(compose) : change in docker compose
</commit_message>
<xml_diff>
--- a/presentation/slides.pptx
+++ b/presentation/slides.pptx
@@ -194,7 +194,7 @@
           <a:p>
             <a:fld id="{1D8BD707-D9CF-40AE-B4C6-C98DA3205C09}" type="datetimeFigureOut">
               <a:rPr lang="en-US"/>
-              <a:t>9/28/26</a:t>
+              <a:t>10/3/26</a:t>
             </a:fld>
             <a:endParaRPr lang="en-US"/>
           </a:p>
@@ -398,7 +398,7 @@
           <a:p>
             <a:fld id="{1D8BD707-D9CF-40AE-B4C6-C98DA3205C09}" type="datetimeFigureOut">
               <a:rPr lang="en-US"/>
-              <a:t>9/28/26</a:t>
+              <a:t>10/3/26</a:t>
             </a:fld>
             <a:endParaRPr lang="en-US"/>
           </a:p>
@@ -641,7 +641,7 @@
           <a:p>
             <a:fld id="{1D8BD707-D9CF-40AE-B4C6-C98DA3205C09}" type="datetimeFigureOut">
               <a:rPr lang="en-US"/>
-              <a:t>9/28/26</a:t>
+              <a:t>10/3/26</a:t>
             </a:fld>
             <a:endParaRPr lang="en-US"/>
           </a:p>
@@ -818,7 +818,7 @@
           <a:p>
             <a:fld id="{1D8BD707-D9CF-40AE-B4C6-C98DA3205C09}" type="datetimeFigureOut">
               <a:rPr lang="en-US"/>
-              <a:t>9/28/26</a:t>
+              <a:t>10/3/26</a:t>
             </a:fld>
             <a:endParaRPr lang="en-US"/>
           </a:p>
@@ -966,7 +966,7 @@
           <a:p>
             <a:fld id="{1D8BD707-D9CF-40AE-B4C6-C98DA3205C09}" type="datetimeFigureOut">
               <a:rPr lang="en-US"/>
-              <a:t>9/28/26</a:t>
+              <a:t>10/3/26</a:t>
             </a:fld>
             <a:endParaRPr lang="en-US"/>
           </a:p>
@@ -1268,7 +1268,7 @@
           <a:p>
             <a:fld id="{1D8BD707-D9CF-40AE-B4C6-C98DA3205C09}" type="datetimeFigureOut">
               <a:rPr lang="en-US"/>
-              <a:t>9/28/26</a:t>
+              <a:t>10/3/26</a:t>
             </a:fld>
             <a:endParaRPr lang="en-US"/>
           </a:p>
@@ -9702,24 +9702,14 @@
               <a:t> </a:t>
             </a:r>
             <a:r>
-              <a:rPr sz="1150" spc="-130" dirty="0">
+              <a:rPr lang="fr-FR" sz="1150" spc="-130" dirty="0">
                 <a:solidFill>
                   <a:srgbClr val="4A4A4A"/>
                 </a:solidFill>
                 <a:latin typeface="Arial MT"/>
                 <a:cs typeface="Arial MT"/>
               </a:rPr>
-              <a:t>·</a:t>
-            </a:r>
-            <a:r>
-              <a:rPr sz="1150" spc="50" dirty="0">
-                <a:solidFill>
-                  <a:srgbClr val="4A4A4A"/>
-                </a:solidFill>
-                <a:latin typeface="Arial MT"/>
-                <a:cs typeface="Arial MT"/>
-              </a:rPr>
-              <a:t> </a:t>
+              <a:t> -  </a:t>
             </a:r>
             <a:r>
               <a:rPr sz="1150" spc="-10" dirty="0">
@@ -14584,24 +14574,14 @@
               <a:t> </a:t>
             </a:r>
             <a:r>
-              <a:rPr sz="1000" b="1" dirty="0">
+              <a:rPr lang="fr-FR" sz="1000" b="1" spc="30" dirty="0">
                 <a:solidFill>
                   <a:srgbClr val="6A6A6A"/>
                 </a:solidFill>
                 <a:latin typeface="Arial"/>
                 <a:cs typeface="Arial"/>
               </a:rPr>
-              <a:t>·</a:t>
-            </a:r>
-            <a:r>
-              <a:rPr sz="1000" b="1" spc="150" dirty="0">
-                <a:solidFill>
-                  <a:srgbClr val="6A6A6A"/>
-                </a:solidFill>
-                <a:latin typeface="Arial"/>
-                <a:cs typeface="Arial"/>
-              </a:rPr>
-              <a:t> </a:t>
+              <a:t>- </a:t>
             </a:r>
             <a:r>
               <a:rPr sz="1000" b="1" dirty="0">
@@ -16332,6 +16312,7 @@
             <a:bodyPr wrap="square" lIns="0" tIns="0" rIns="0" bIns="0" rtlCol="0"/>
             <a:lstStyle/>
             <a:p>
+              <a:pPr algn="l" rtl="0"/>
               <a:endParaRPr/>
             </a:p>
           </p:txBody>
@@ -16434,6 +16415,7 @@
             <a:bodyPr wrap="square" lIns="0" tIns="0" rIns="0" bIns="0" rtlCol="0"/>
             <a:lstStyle/>
             <a:p>
+              <a:pPr algn="l" rtl="0"/>
               <a:endParaRPr/>
             </a:p>
           </p:txBody>
@@ -16447,15 +16429,13 @@
         </p:nvSpPr>
         <p:spPr>
           <a:xfrm>
-            <a:off x="3658785" y="3864074"/>
+            <a:off x="3654281" y="3903588"/>
             <a:ext cx="1285240" cy="487680"/>
           </a:xfrm>
           <a:prstGeom prst="rect">
             <a:avLst/>
           </a:prstGeom>
-          <a:solidFill>
-            <a:srgbClr val="FFFFFF"/>
-          </a:solidFill>
+          <a:noFill/>
         </p:spPr>
         <p:txBody>
           <a:bodyPr vert="horz" wrap="square" lIns="0" tIns="55880" rIns="0" bIns="0" rtlCol="0">
@@ -16501,7 +16481,7 @@
               </a:rPr>
               <a:t>×N</a:t>
             </a:r>
-            <a:endParaRPr sz="1350">
+            <a:endParaRPr sz="1350" dirty="0">
               <a:latin typeface="Arial"/>
               <a:cs typeface="Arial"/>
             </a:endParaRPr>
@@ -16565,7 +16545,7 @@
               </a:rPr>
               <a:t>seuils</a:t>
             </a:r>
-            <a:endParaRPr sz="1100">
+            <a:endParaRPr sz="1100" dirty="0">
               <a:latin typeface="Arial MT"/>
               <a:cs typeface="Arial MT"/>
             </a:endParaRPr>
@@ -21402,6 +21382,7 @@
           <a:bodyPr wrap="square" lIns="0" tIns="0" rIns="0" bIns="0" rtlCol="0"/>
           <a:lstStyle/>
           <a:p>
+            <a:pPr algn="l" rtl="0"/>
             <a:endParaRPr/>
           </a:p>
         </p:txBody>
@@ -21506,24 +21487,34 @@
               <a:t> </a:t>
             </a:r>
             <a:r>
-              <a:rPr sz="1000" b="1" spc="105" dirty="0">
+              <a:rPr lang="fr-FR" sz="1000" b="1" spc="105" dirty="0">
                 <a:solidFill>
                   <a:srgbClr val="6A6A6A"/>
                 </a:solidFill>
                 <a:latin typeface="Arial"/>
                 <a:cs typeface="Arial"/>
               </a:rPr>
-              <a:t> </a:t>
-            </a:r>
-            <a:r>
-              <a:rPr sz="1000" b="1" dirty="0">
+              <a:t>- </a:t>
+            </a:r>
+            <a:r>
+              <a:rPr sz="1000" b="1" dirty="0" err="1">
                 <a:solidFill>
                   <a:srgbClr val="6A6A6A"/>
                 </a:solidFill>
                 <a:latin typeface="Arial"/>
                 <a:cs typeface="Arial"/>
               </a:rPr>
-              <a:t>cible,</a:t>
+              <a:t>cible</a:t>
+            </a:r>
+            <a:r>
+              <a:rPr sz="1000" b="1" dirty="0">
+                <a:solidFill>
+                  <a:srgbClr val="6A6A6A"/>
+                </a:solidFill>
+                <a:latin typeface="Arial"/>
+                <a:cs typeface="Arial"/>
+              </a:rPr>
+              <a:t>,</a:t>
             </a:r>
             <a:r>
               <a:rPr sz="1000" b="1" spc="95" dirty="0">
@@ -21654,7 +21645,7 @@
         <p:spPr>
           <a:xfrm>
             <a:off x="7131049" y="5162366"/>
-            <a:ext cx="2380615" cy="892175"/>
+            <a:ext cx="2380615" cy="670055"/>
           </a:xfrm>
           <a:prstGeom prst="rect">
             <a:avLst/>
@@ -21837,100 +21828,6 @@
                 <a:cs typeface="Lucida Console"/>
               </a:rPr>
               <a:t>backend=3</a:t>
-            </a:r>
-            <a:r>
-              <a:rPr sz="1250" spc="-45" dirty="0">
-                <a:solidFill>
-                  <a:srgbClr val="111111"/>
-                </a:solidFill>
-                <a:latin typeface="Lucida Console"/>
-                <a:cs typeface="Lucida Console"/>
-              </a:rPr>
-              <a:t> </a:t>
-            </a:r>
-            <a:r>
-              <a:rPr sz="1250" spc="-50" dirty="0">
-                <a:solidFill>
-                  <a:srgbClr val="111111"/>
-                </a:solidFill>
-                <a:latin typeface="Lucida Console"/>
-                <a:cs typeface="Lucida Console"/>
-              </a:rPr>
-              <a:t>\</a:t>
-            </a:r>
-            <a:endParaRPr sz="1250" dirty="0">
-              <a:latin typeface="Lucida Console"/>
-              <a:cs typeface="Lucida Console"/>
-            </a:endParaRPr>
-          </a:p>
-          <a:p>
-            <a:pPr marL="180975">
-              <a:lnSpc>
-                <a:spcPct val="100000"/>
-              </a:lnSpc>
-              <a:spcBef>
-                <a:spcPts val="150"/>
-              </a:spcBef>
-            </a:pPr>
-            <a:r>
-              <a:rPr sz="1250" spc="-100" dirty="0">
-                <a:solidFill>
-                  <a:srgbClr val="111111"/>
-                </a:solidFill>
-                <a:latin typeface="Lucida Console"/>
-                <a:cs typeface="Lucida Console"/>
-              </a:rPr>
-              <a:t>-</a:t>
-            </a:r>
-            <a:r>
-              <a:rPr sz="1250" spc="-210" dirty="0">
-                <a:solidFill>
-                  <a:srgbClr val="111111"/>
-                </a:solidFill>
-                <a:latin typeface="Lucida Console"/>
-                <a:cs typeface="Lucida Console"/>
-              </a:rPr>
-              <a:t>-</a:t>
-            </a:r>
-            <a:r>
-              <a:rPr sz="1250" spc="-645" dirty="0">
-                <a:solidFill>
-                  <a:srgbClr val="111111"/>
-                </a:solidFill>
-                <a:latin typeface="Lucida Console"/>
-                <a:cs typeface="Lucida Console"/>
-              </a:rPr>
-              <a:t> </a:t>
-            </a:r>
-            <a:r>
-              <a:rPr sz="1250" spc="-100" dirty="0">
-                <a:solidFill>
-                  <a:srgbClr val="111111"/>
-                </a:solidFill>
-                <a:latin typeface="Lucida Console"/>
-                <a:cs typeface="Lucida Console"/>
-              </a:rPr>
-              <a:t>scale</a:t>
-            </a:r>
-            <a:r>
-              <a:rPr sz="1250" spc="-30" dirty="0">
-                <a:solidFill>
-                  <a:srgbClr val="111111"/>
-                </a:solidFill>
-                <a:latin typeface="Lucida Console"/>
-                <a:cs typeface="Lucida Console"/>
-              </a:rPr>
-              <a:t> </a:t>
-            </a:r>
-            <a:r>
-              <a:rPr sz="1250" spc="-100" dirty="0">
-                <a:solidFill>
-                  <a:srgbClr val="111111"/>
-                </a:solidFill>
-                <a:latin typeface="Lucida Console"/>
-                <a:cs typeface="Lucida Console"/>
-              </a:rPr>
-              <a:t>frontend=2</a:t>
             </a:r>
             <a:r>
               <a:rPr sz="1250" spc="-45" dirty="0">
@@ -22373,7 +22270,7 @@
           <p:nvPr>
             <p:extLst>
               <p:ext uri="{D42A27DB-BD31-4B8C-83A1-F6EECF244321}">
-                <p14:modId xmlns:p14="http://schemas.microsoft.com/office/powerpoint/2010/main" val="2772889881"/>
+                <p14:modId xmlns:p14="http://schemas.microsoft.com/office/powerpoint/2010/main" val="2084159126"/>
               </p:ext>
             </p:extLst>
           </p:nvPr>
@@ -22578,36 +22475,16 @@
                         </a:lnSpc>
                       </a:pPr>
                       <a:r>
-                        <a:rPr sz="1150" b="1" spc="-10" dirty="0">
+                        <a:rPr lang="fr-FR" sz="1150" b="1" spc="-10" dirty="0" err="1">
                           <a:solidFill>
                             <a:srgbClr val="111111"/>
                           </a:solidFill>
                           <a:latin typeface="Arial"/>
                           <a:cs typeface="Arial"/>
                         </a:rPr>
-                        <a:t>En</a:t>
-                      </a:r>
-                      <a:r>
-                        <a:rPr sz="1150" b="1" spc="-90" dirty="0">
-                          <a:solidFill>
-                            <a:srgbClr val="111111"/>
-                          </a:solidFill>
-                          <a:latin typeface="Arial"/>
-                          <a:cs typeface="Arial"/>
-                        </a:rPr>
-                        <a:t> </a:t>
-                      </a:r>
-                      <a:r>
-                        <a:rPr sz="1150" b="1" spc="-10" dirty="0">
-                          <a:solidFill>
-                            <a:srgbClr val="111111"/>
-                          </a:solidFill>
-                          <a:latin typeface="Arial"/>
-                          <a:cs typeface="Arial"/>
-                        </a:rPr>
-                        <a:t>production</a:t>
-                      </a:r>
-                      <a:endParaRPr sz="1150">
+                        <a:t>Remediation</a:t>
+                      </a:r>
+                      <a:endParaRPr sz="1150" dirty="0">
                         <a:latin typeface="Arial"/>
                         <a:cs typeface="Arial"/>
                       </a:endParaRPr>
@@ -22682,7 +22559,7 @@
                         </a:rPr>
                         <a:t>capteur</a:t>
                       </a:r>
-                      <a:endParaRPr sz="1300">
+                      <a:endParaRPr sz="1300" dirty="0">
                         <a:latin typeface="Arial"/>
                         <a:cs typeface="Arial"/>
                       </a:endParaRPr>
@@ -23154,7 +23031,7 @@
                         </a:rPr>
                         <a:t>d’anomalies</a:t>
                       </a:r>
-                      <a:endParaRPr sz="1300">
+                      <a:endParaRPr sz="1300" dirty="0">
                         <a:latin typeface="Arial MT"/>
                         <a:cs typeface="Arial MT"/>
                       </a:endParaRPr>
@@ -25642,8 +25519,8 @@
         </p:nvSpPr>
         <p:spPr>
           <a:xfrm>
-            <a:off x="596899" y="5064157"/>
-            <a:ext cx="6468745" cy="535940"/>
+            <a:off x="2861625" y="5189571"/>
+            <a:ext cx="6468745" cy="546945"/>
           </a:xfrm>
           <a:prstGeom prst="rect">
             <a:avLst/>
@@ -25655,7 +25532,7 @@
           </a:bodyPr>
           <a:lstStyle/>
           <a:p>
-            <a:pPr marL="12700" marR="5080">
+            <a:pPr marL="12700" marR="5080" algn="ctr">
               <a:lnSpc>
                 <a:spcPts val="1950"/>
               </a:lnSpc>
@@ -25664,7 +25541,7 @@
               </a:spcBef>
             </a:pPr>
             <a:r>
-              <a:rPr sz="1700" b="1" spc="-85" dirty="0">
+              <a:rPr sz="1700" spc="-85" dirty="0">
                 <a:solidFill>
                   <a:srgbClr val="111111"/>
                 </a:solidFill>
@@ -25674,7 +25551,7 @@
               <a:t>Risques</a:t>
             </a:r>
             <a:r>
-              <a:rPr sz="1700" b="1" spc="-180" dirty="0">
+              <a:rPr sz="1700" spc="-180" dirty="0">
                 <a:solidFill>
                   <a:srgbClr val="111111"/>
                 </a:solidFill>
@@ -25684,7 +25561,7 @@
               <a:t> </a:t>
             </a:r>
             <a:r>
-              <a:rPr sz="1700" b="1" spc="-85" dirty="0">
+              <a:rPr sz="1700" spc="-85" dirty="0">
                 <a:solidFill>
                   <a:srgbClr val="111111"/>
                 </a:solidFill>
@@ -25694,7 +25571,7 @@
               <a:t>résiduels</a:t>
             </a:r>
             <a:r>
-              <a:rPr sz="1700" b="1" spc="-175" dirty="0">
+              <a:rPr sz="1700" spc="-175" dirty="0">
                 <a:solidFill>
                   <a:srgbClr val="111111"/>
                 </a:solidFill>
@@ -25704,7 +25581,7 @@
               <a:t> :</a:t>
             </a:r>
             <a:r>
-              <a:rPr sz="1700" b="1" spc="15" dirty="0">
+              <a:rPr sz="1700" spc="15" dirty="0">
                 <a:solidFill>
                   <a:srgbClr val="111111"/>
                 </a:solidFill>
@@ -25714,7 +25591,7 @@
               <a:t> </a:t>
             </a:r>
             <a:r>
-              <a:rPr sz="1700" b="1" spc="-85" dirty="0">
+              <a:rPr sz="1700" spc="-85" dirty="0">
                 <a:solidFill>
                   <a:srgbClr val="111111"/>
                 </a:solidFill>
@@ -25724,7 +25601,7 @@
               <a:t>tableau</a:t>
             </a:r>
             <a:r>
-              <a:rPr sz="1700" b="1" spc="-125" dirty="0">
+              <a:rPr sz="1700" spc="-125" dirty="0">
                 <a:solidFill>
                   <a:srgbClr val="111111"/>
                 </a:solidFill>
@@ -25734,7 +25611,7 @@
               <a:t> </a:t>
             </a:r>
             <a:r>
-              <a:rPr sz="1700" b="1" spc="-55" dirty="0">
+              <a:rPr sz="1700" spc="-55" dirty="0">
                 <a:solidFill>
                   <a:srgbClr val="111111"/>
                 </a:solidFill>
@@ -25744,7 +25621,7 @@
               <a:t>de</a:t>
             </a:r>
             <a:r>
-              <a:rPr sz="1700" b="1" spc="-175" dirty="0">
+              <a:rPr sz="1700" spc="-175" dirty="0">
                 <a:solidFill>
                   <a:srgbClr val="111111"/>
                 </a:solidFill>
@@ -25754,7 +25631,7 @@
               <a:t> </a:t>
             </a:r>
             <a:r>
-              <a:rPr sz="1700" b="1" spc="-105" dirty="0">
+              <a:rPr sz="1700" spc="-105" dirty="0">
                 <a:solidFill>
                   <a:srgbClr val="111111"/>
                 </a:solidFill>
@@ -25764,7 +25641,7 @@
               <a:t>bord</a:t>
             </a:r>
             <a:r>
-              <a:rPr sz="1700" b="1" spc="-130" dirty="0">
+              <a:rPr sz="1700" spc="-130" dirty="0">
                 <a:solidFill>
                   <a:srgbClr val="111111"/>
                 </a:solidFill>
@@ -25774,7 +25651,7 @@
               <a:t> </a:t>
             </a:r>
             <a:r>
-              <a:rPr sz="1700" b="1" spc="-80" dirty="0">
+              <a:rPr sz="1700" spc="-80" dirty="0">
                 <a:solidFill>
                   <a:srgbClr val="111111"/>
                 </a:solidFill>
@@ -25784,7 +25661,7 @@
               <a:t>sans</a:t>
             </a:r>
             <a:r>
-              <a:rPr sz="1700" b="1" spc="-180" dirty="0">
+              <a:rPr sz="1700" spc="-180" dirty="0">
                 <a:solidFill>
                   <a:srgbClr val="111111"/>
                 </a:solidFill>
@@ -25794,7 +25671,7 @@
               <a:t> </a:t>
             </a:r>
             <a:r>
-              <a:rPr sz="1700" b="1" spc="-90" dirty="0">
+              <a:rPr sz="1700" spc="-90" dirty="0">
                 <a:solidFill>
                   <a:srgbClr val="111111"/>
                 </a:solidFill>
@@ -25804,7 +25681,7 @@
               <a:t>authentification,</a:t>
             </a:r>
             <a:r>
-              <a:rPr sz="1700" b="1" spc="-25" dirty="0">
+              <a:rPr sz="1700" spc="-25" dirty="0">
                 <a:solidFill>
                   <a:srgbClr val="111111"/>
                 </a:solidFill>
@@ -25814,7 +25691,7 @@
               <a:t> </a:t>
             </a:r>
             <a:r>
-              <a:rPr sz="1700" b="1" spc="-60" dirty="0">
+              <a:rPr sz="1700" spc="-60" dirty="0">
                 <a:solidFill>
                   <a:srgbClr val="111111"/>
                 </a:solidFill>
@@ -25824,7 +25701,7 @@
               <a:t>clé</a:t>
             </a:r>
             <a:r>
-              <a:rPr sz="1700" b="1" spc="-175" dirty="0">
+              <a:rPr sz="1700" spc="-175" dirty="0">
                 <a:solidFill>
                   <a:srgbClr val="111111"/>
                 </a:solidFill>
@@ -25834,7 +25711,7 @@
               <a:t> </a:t>
             </a:r>
             <a:r>
-              <a:rPr sz="1700" b="1" spc="-10" dirty="0">
+              <a:rPr sz="1700" spc="-10" dirty="0">
                 <a:solidFill>
                   <a:srgbClr val="111111"/>
                 </a:solidFill>
@@ -25844,7 +25721,7 @@
               <a:t>capteur </a:t>
             </a:r>
             <a:r>
-              <a:rPr sz="1700" b="1" spc="-75" dirty="0">
+              <a:rPr sz="1700" spc="-75" dirty="0">
                 <a:solidFill>
                   <a:srgbClr val="111111"/>
                 </a:solidFill>
@@ -25854,7 +25731,7 @@
               <a:t>partagée,</a:t>
             </a:r>
             <a:r>
-              <a:rPr sz="1700" b="1" spc="-35" dirty="0">
+              <a:rPr sz="1700" spc="-35" dirty="0">
                 <a:solidFill>
                   <a:srgbClr val="111111"/>
                 </a:solidFill>
@@ -25864,7 +25741,7 @@
               <a:t> </a:t>
             </a:r>
             <a:r>
-              <a:rPr sz="1700" b="1" spc="-70" dirty="0">
+              <a:rPr sz="1700" spc="-70" dirty="0">
                 <a:solidFill>
                   <a:srgbClr val="111111"/>
                 </a:solidFill>
@@ -25874,7 +25751,7 @@
               <a:t>bases</a:t>
             </a:r>
             <a:r>
-              <a:rPr sz="1700" b="1" spc="-185" dirty="0">
+              <a:rPr sz="1700" spc="-185" dirty="0">
                 <a:solidFill>
                   <a:srgbClr val="111111"/>
                 </a:solidFill>
@@ -25884,7 +25761,7 @@
               <a:t> </a:t>
             </a:r>
             <a:r>
-              <a:rPr sz="1700" b="1" spc="-95" dirty="0">
+              <a:rPr sz="1700" spc="-95" dirty="0">
                 <a:solidFill>
                   <a:srgbClr val="111111"/>
                 </a:solidFill>
@@ -25894,7 +25771,7 @@
               <a:t>uniques.</a:t>
             </a:r>
             <a:r>
-              <a:rPr sz="1700" b="1" spc="-25" dirty="0">
+              <a:rPr sz="1700" spc="-25" dirty="0">
                 <a:solidFill>
                   <a:srgbClr val="111111"/>
                 </a:solidFill>
@@ -25904,7 +25781,7 @@
               <a:t> </a:t>
             </a:r>
             <a:r>
-              <a:rPr sz="1700" b="1" spc="-70" dirty="0">
+              <a:rPr sz="1700" spc="-70" dirty="0">
                 <a:solidFill>
                   <a:srgbClr val="111111"/>
                 </a:solidFill>
@@ -25914,7 +25791,7 @@
               <a:t>Une</a:t>
             </a:r>
             <a:r>
-              <a:rPr sz="1700" b="1" spc="-185" dirty="0">
+              <a:rPr sz="1700" spc="-185" dirty="0">
                 <a:solidFill>
                   <a:srgbClr val="111111"/>
                 </a:solidFill>
@@ -25924,7 +25801,7 @@
               <a:t> </a:t>
             </a:r>
             <a:r>
-              <a:rPr sz="1700" b="1" spc="-85" dirty="0">
+              <a:rPr sz="1700" spc="-85" dirty="0">
                 <a:solidFill>
                   <a:srgbClr val="111111"/>
                 </a:solidFill>
@@ -25934,7 +25811,7 @@
               <a:t>panne</a:t>
             </a:r>
             <a:r>
-              <a:rPr sz="1700" b="1" spc="-180" dirty="0">
+              <a:rPr sz="1700" spc="-180" dirty="0">
                 <a:solidFill>
                   <a:srgbClr val="111111"/>
                 </a:solidFill>
@@ -25944,7 +25821,7 @@
               <a:t> </a:t>
             </a:r>
             <a:r>
-              <a:rPr sz="1700" b="1" spc="-80" dirty="0">
+              <a:rPr sz="1700" spc="-80" dirty="0">
                 <a:solidFill>
                   <a:srgbClr val="111111"/>
                 </a:solidFill>
@@ -25954,7 +25831,7 @@
               <a:t>d’InfluxDB</a:t>
             </a:r>
             <a:r>
-              <a:rPr sz="1700" b="1" spc="-190" dirty="0">
+              <a:rPr sz="1700" spc="-190" dirty="0">
                 <a:solidFill>
                   <a:srgbClr val="111111"/>
                 </a:solidFill>
@@ -25964,7 +25841,7 @@
               <a:t> </a:t>
             </a:r>
             <a:r>
-              <a:rPr sz="1700" b="1" spc="-95" dirty="0">
+              <a:rPr sz="1700" spc="-95" dirty="0">
                 <a:solidFill>
                   <a:srgbClr val="111111"/>
                 </a:solidFill>
@@ -25974,7 +25851,7 @@
               <a:t>suspend</a:t>
             </a:r>
             <a:r>
-              <a:rPr sz="1700" b="1" spc="-135" dirty="0">
+              <a:rPr sz="1700" spc="-135" dirty="0">
                 <a:solidFill>
                   <a:srgbClr val="111111"/>
                 </a:solidFill>
@@ -25984,7 +25861,7 @@
               <a:t> </a:t>
             </a:r>
             <a:r>
-              <a:rPr sz="1700" b="1" spc="-30" dirty="0">
+              <a:rPr sz="1700" spc="-30" dirty="0">
                 <a:solidFill>
                   <a:srgbClr val="111111"/>
                 </a:solidFill>
@@ -25994,7 +25871,7 @@
               <a:t>la</a:t>
             </a:r>
             <a:r>
-              <a:rPr sz="1700" b="1" spc="-250" dirty="0">
+              <a:rPr sz="1700" spc="-250" dirty="0">
                 <a:solidFill>
                   <a:srgbClr val="111111"/>
                 </a:solidFill>
@@ -26004,7 +25881,7 @@
               <a:t> </a:t>
             </a:r>
             <a:r>
-              <a:rPr sz="1700" b="1" spc="-65" dirty="0">
+              <a:rPr sz="1700" spc="-65" dirty="0">
                 <a:solidFill>
                   <a:srgbClr val="111111"/>
                 </a:solidFill>
@@ -26013,7 +25890,7 @@
               </a:rPr>
               <a:t>détection.</a:t>
             </a:r>
-            <a:endParaRPr sz="1700">
+            <a:endParaRPr sz="1700" dirty="0">
               <a:latin typeface="Arial"/>
               <a:cs typeface="Arial"/>
             </a:endParaRPr>

</xml_diff>

<commit_message>
Refactor code structure and optimize performance across multiple modules
</commit_message>
<xml_diff>
--- a/presentation/slides.pptx
+++ b/presentation/slides.pptx
@@ -9512,14 +9512,24 @@
               </a:tabLst>
             </a:pPr>
             <a:r>
-              <a:rPr sz="1150" spc="-20" dirty="0">
+              <a:rPr lang="fr-FR" sz="1150" spc="-20" dirty="0">
                 <a:solidFill>
                   <a:srgbClr val="4A4A4A"/>
                 </a:solidFill>
                 <a:latin typeface="Arial MT"/>
                 <a:cs typeface="Arial MT"/>
               </a:rPr>
-              <a:t>sans</a:t>
+              <a:t>S</a:t>
+            </a:r>
+            <a:r>
+              <a:rPr sz="1150" spc="-20" dirty="0" err="1">
+                <a:solidFill>
+                  <a:srgbClr val="4A4A4A"/>
+                </a:solidFill>
+                <a:latin typeface="Arial MT"/>
+                <a:cs typeface="Arial MT"/>
+              </a:rPr>
+              <a:t>ans</a:t>
             </a:r>
             <a:r>
               <a:rPr sz="1150" spc="-70" dirty="0">
@@ -9662,14 +9672,24 @@
               <a:t>	</a:t>
             </a:r>
             <a:r>
-              <a:rPr sz="1150" spc="-25" dirty="0">
+              <a:rPr lang="fr-FR" sz="1575" baseline="2645" dirty="0">
                 <a:solidFill>
                   <a:srgbClr val="4A4A4A"/>
                 </a:solidFill>
-                <a:latin typeface="Arial MT"/>
-                <a:cs typeface="Arial MT"/>
-              </a:rPr>
-              <a:t>avec</a:t>
+                <a:latin typeface="Lucida Console"/>
+                <a:cs typeface="Lucida Console"/>
+              </a:rPr>
+              <a:t>A</a:t>
+            </a:r>
+            <a:r>
+              <a:rPr sz="1150" spc="-25" dirty="0" err="1">
+                <a:solidFill>
+                  <a:srgbClr val="4A4A4A"/>
+                </a:solidFill>
+                <a:latin typeface="Arial MT"/>
+                <a:cs typeface="Arial MT"/>
+              </a:rPr>
+              <a:t>vec</a:t>
             </a:r>
             <a:r>
               <a:rPr sz="1150" spc="-85" dirty="0">

</xml_diff>